<commit_message>
Restructure to 7 slides: cover is now a pure intro; new 'Meet Natalie' slide (Cape Town) carries her story
</commit_message>
<xml_diff>
--- a/downloads/Luchelle_Crafford_My_South_African_Hero.pptx
+++ b/downloads/Luchelle_Crafford_My_South_African_Hero.pptx
@@ -11,6 +11,7 @@
     <p:sldId id="259" r:id="rId11"/>
     <p:sldId id="260" r:id="rId12"/>
     <p:sldId id="261" r:id="rId13"/>
+    <p:sldId id="262" r:id="rId14"/>
   </p:sldIdLst>
   <p:sldSz cx="12191695" cy="6858000" type="screen4x3"/>
   <p:notesSz cx="6858000" cy="9144000"/>
@@ -507,7 +508,7 @@
           <a:lstStyle/>
           <a:p>
             <a:r>
-              <a:t>Good day everyone. My South African hero is Natalie du Toit. Natalie is a famous South African swimmer. She was born in Cape Town and loved swimming from a young age.</a:t>
+              <a:t>Good day everyone. My South African hero is Natalie du Toit.</a:t>
             </a:r>
           </a:p>
         </p:txBody>
@@ -577,7 +578,7 @@
           <a:lstStyle/>
           <a:p>
             <a:r>
-              <a:t>When Natalie was 17 years old, she was involved in a serious scooter accident. Doctors had to amputate her left leg. That could have stopped her from following her dreams. However, she was brave and did not give up.</a:t>
+              <a:t>Natalie is a famous South African swimmer. She was born in Cape Town and loved swimming from a young age.</a:t>
             </a:r>
           </a:p>
         </p:txBody>
@@ -647,7 +648,7 @@
           <a:lstStyle/>
           <a:p>
             <a:r>
-              <a:t>Natalie worked hard every day and started swimming again. She became a champion Paralympic swimmer. She even competed against swimmers without disabilities.</a:t>
+              <a:t>When Natalie was 17 years old, she was involved in a serious scooter accident. Doctors had to amputate her left leg. That could have stopped her from following her dreams. However, she was brave and did not give up.</a:t>
             </a:r>
           </a:p>
         </p:txBody>
@@ -717,7 +718,7 @@
           <a:lstStyle/>
           <a:p>
             <a:r>
-              <a:t>Natalie represented South Africa at the 2008 Olympic Games in Beijing. She competed in the 10-kilometre open-water race and showed that courage can take you further than anyone expects.</a:t>
+              <a:t>Natalie worked hard every day and started swimming again. She became a champion Paralympic swimmer. She even competed against swimmers without disabilities.</a:t>
             </a:r>
           </a:p>
         </p:txBody>
@@ -787,7 +788,7 @@
           <a:lstStyle/>
           <a:p>
             <a:r>
-              <a:t>I chose Natalie du Toit as my South African hero because she was a great swimmer, but more importantly, she never gave up on her dream. Her story makes me feel proud. She showed the world what a South African can achieve with courage and hard work.</a:t>
+              <a:t>Natalie represented South Africa at the 2008 Olympic Games in Beijing. She competed in the 10-kilometre open-water race and showed that courage can take you further than anyone expects.</a:t>
             </a:r>
           </a:p>
         </p:txBody>
@@ -857,13 +858,83 @@
           <a:lstStyle/>
           <a:p>
             <a:r>
+              <a:t>I chose Natalie du Toit as my South African hero because she was a great swimmer, but more importantly, she never gave up on her dream. Her story makes me feel proud. She showed the world what a South African can achieve with courage and hard work.</a:t>
+            </a:r>
+          </a:p>
+        </p:txBody>
+      </p:sp>
+      <p:sp>
+        <p:nvSpPr>
+          <p:cNvPr id="4" name="Slide Number Placeholder 3"/>
+          <p:cNvSpPr>
+            <a:spLocks noGrp="1"/>
+          </p:cNvSpPr>
+          <p:nvPr>
+            <p:ph type="sldNum" idx="5" sz="quarter"/>
+          </p:nvPr>
+        </p:nvSpPr>
+        <p:spPr/>
+      </p:sp>
+    </p:spTree>
+  </p:cSld>
+  <p:clrMapOvr>
+    <a:masterClrMapping/>
+  </p:clrMapOvr>
+</p:notes>
+</file>
+
+<file path=ppt/notesSlides/notesSlide7.xml><?xml version="1.0" encoding="utf-8"?>
+<p:notes xmlns:a="http://schemas.openxmlformats.org/drawingml/2006/main" xmlns:p="http://schemas.openxmlformats.org/presentationml/2006/main" xmlns:r="http://schemas.openxmlformats.org/officeDocument/2006/relationships">
+  <p:cSld>
+    <p:spTree>
+      <p:nvGrpSpPr>
+        <p:cNvPr id="1" name=""/>
+        <p:cNvGrpSpPr/>
+        <p:nvPr/>
+      </p:nvGrpSpPr>
+      <p:grpSpPr>
+        <a:xfrm>
+          <a:off x="0" y="0"/>
+          <a:ext cx="0" cy="0"/>
+          <a:chOff x="0" y="0"/>
+          <a:chExt cx="0" cy="0"/>
+        </a:xfrm>
+      </p:grpSpPr>
+      <p:sp>
+        <p:nvSpPr>
+          <p:cNvPr id="2" name="Slide Image Placeholder 1"/>
+          <p:cNvSpPr>
+            <a:spLocks noGrp="1"/>
+          </p:cNvSpPr>
+          <p:nvPr>
+            <p:ph type="sldImg" idx="2"/>
+          </p:nvPr>
+        </p:nvSpPr>
+        <p:spPr/>
+      </p:sp>
+      <p:sp>
+        <p:nvSpPr>
+          <p:cNvPr id="3" name="Notes Placeholder 2"/>
+          <p:cNvSpPr>
+            <a:spLocks noGrp="1"/>
+          </p:cNvSpPr>
+          <p:nvPr>
+            <p:ph type="body" idx="3" sz="quarter"/>
+          </p:nvPr>
+        </p:nvSpPr>
+        <p:spPr/>
+        <p:txBody>
+          <a:bodyPr/>
+          <a:lstStyle/>
+          <a:p>
+            <a:r>
               <a:t>Natalie taught me that when something difficult happens, I must keep trying, believe in myself, work hard, and never give up. If Natalie were standing in front of me today, I would say: Natalie, you are a great swimmer, and you inspire me to never give up on my dreams. Thank you for listening.</a:t>
             </a:r>
           </a:p>
           <a:p/>
           <a:p>
             <a:r>
-              <a:t>SOURCES (facts verified 1 September 2026): Encyclopaedia Britannica - Natalie du Toit (britannica.com/biography/Natalie-du-Toit); ESPN/AP, 3 May 2008 (espn.com/olympics/swimming/news/story?id=3379722); The Independent - 'If I can achieve a dream, then anyone can'; Paralympic.org - The day Natalie du Toit made Olympic history. IMAGE CREDITS: Beijing 2008 medal photo - Heath Campanaro / Australian Paralympic Committee, via Wikimedia Commons, CC BY-SA 3.0; swimming photo via Commonwealth Sport; Laureus photo via swimhistory.co.za; school crest - Panorama Primary School (panoramaps.co.za); photographs of Luchelle supplied by the Crafford family.</a:t>
+              <a:t>SOURCES (facts verified 1 September 2026): Encyclopaedia Britannica - Natalie du Toit (britannica.com/biography/Natalie-du-Toit); ESPN/AP, 3 May 2008 (espn.com/olympics/swimming/news/story?id=3379722); The Independent - 'If I can achieve a dream, then anyone can'; Paralympic.org - The day Natalie du Toit made Olympic history. IMAGE CREDITS: Beijing 2008 medal photo - Heath Campanaro / Australian Paralympic Committee, via Wikimedia Commons, CC BY-SA 3.0; swimming photo via Commonwealth Sport; Cape Town training photo and Laureus photo via swimhistory.co.za; school crest - Panorama Primary School (panoramaps.co.za); photographs of Luchelle supplied by the Crafford family.</a:t>
             </a:r>
           </a:p>
         </p:txBody>
@@ -4142,7 +4213,7 @@
         <p:spPr>
           <a:xfrm>
             <a:off x="0" y="6794500"/>
-            <a:ext cx="2031949" cy="63500"/>
+            <a:ext cx="1741670" cy="63500"/>
           </a:xfrm>
           <a:prstGeom prst="rect">
             <a:avLst/>
@@ -4216,7 +4287,7 @@
                 </a:solidFill>
                 <a:latin typeface="Arial"/>
               </a:rPr>
-              <a:t> / 06</a:t>
+              <a:t> / 07</a:t>
             </a:r>
           </a:p>
         </p:txBody>
@@ -4558,50 +4629,6 @@
             <a:avLst/>
           </a:prstGeom>
           <a:solidFill>
-            <a:srgbClr val="FFF6E5"/>
-          </a:solidFill>
-          <a:ln>
-            <a:noFill/>
-          </a:ln>
-          <a:effectLst/>
-        </p:spPr>
-        <p:style>
-          <a:lnRef idx="1">
-            <a:schemeClr val="accent1"/>
-          </a:lnRef>
-          <a:fillRef idx="3">
-            <a:schemeClr val="accent1"/>
-          </a:fillRef>
-          <a:effectRef idx="2">
-            <a:schemeClr val="accent1"/>
-          </a:effectRef>
-          <a:fontRef idx="minor">
-            <a:schemeClr val="lt1"/>
-          </a:fontRef>
-        </p:style>
-        <p:txBody>
-          <a:bodyPr rtlCol="0" anchor="ctr"/>
-          <a:lstStyle/>
-          <a:p>
-            <a:pPr algn="ctr"/>
-          </a:p>
-        </p:txBody>
-      </p:sp>
-      <p:sp>
-        <p:nvSpPr>
-          <p:cNvPr id="3" name="Rectangle 2"/>
-          <p:cNvSpPr/>
-          <p:nvPr/>
-        </p:nvSpPr>
-        <p:spPr>
-          <a:xfrm>
-            <a:off x="0" y="0"/>
-            <a:ext cx="3977639" cy="6858000"/>
-          </a:xfrm>
-          <a:prstGeom prst="rect">
-            <a:avLst/>
-          </a:prstGeom>
-          <a:solidFill>
             <a:srgbClr val="004B36"/>
           </a:solidFill>
           <a:ln>
@@ -4633,257 +4660,16 @@
       </p:sp>
       <p:sp>
         <p:nvSpPr>
-          <p:cNvPr id="4" name="TextBox 3"/>
-          <p:cNvSpPr txBox="1"/>
-          <p:nvPr/>
-        </p:nvSpPr>
-        <p:spPr>
-          <a:xfrm>
-            <a:off x="685800" y="1737360"/>
-            <a:ext cx="3017520" cy="2011680"/>
-          </a:xfrm>
-          <a:prstGeom prst="rect">
-            <a:avLst/>
-          </a:prstGeom>
-          <a:noFill/>
-        </p:spPr>
-        <p:txBody>
-          <a:bodyPr wrap="square" anchor="t" lIns="0" rIns="0" tIns="0" bIns="0">
-            <a:spAutoFit/>
-          </a:bodyPr>
-          <a:lstStyle/>
-          <a:p>
-            <a:pPr algn="l"/>
-            <a:r>
-              <a:rPr sz="15000" b="1" i="0">
-                <a:solidFill>
-                  <a:srgbClr val="FFB81C"/>
-                </a:solidFill>
-                <a:latin typeface="Arial"/>
-              </a:rPr>
-              <a:t>17</a:t>
-            </a:r>
-          </a:p>
-        </p:txBody>
-      </p:sp>
-      <p:sp>
-        <p:nvSpPr>
-          <p:cNvPr id="5" name="TextBox 4"/>
-          <p:cNvSpPr txBox="1"/>
-          <p:nvPr/>
-        </p:nvSpPr>
-        <p:spPr>
-          <a:xfrm>
-            <a:off x="749808" y="3977639"/>
-            <a:ext cx="2926080" cy="457200"/>
-          </a:xfrm>
-          <a:prstGeom prst="rect">
-            <a:avLst/>
-          </a:prstGeom>
-          <a:noFill/>
-        </p:spPr>
-        <p:txBody>
-          <a:bodyPr wrap="square" anchor="t" lIns="0" rIns="0" tIns="0" bIns="0">
-            <a:spAutoFit/>
-          </a:bodyPr>
-          <a:lstStyle/>
-          <a:p>
-            <a:pPr algn="l"/>
-            <a:r>
-              <a:rPr sz="2400" b="1" i="0" spc="400">
-                <a:solidFill>
-                  <a:srgbClr val="FFFFFF"/>
-                </a:solidFill>
-                <a:latin typeface="Arial"/>
-              </a:rPr>
-              <a:t>YEARS OLD</a:t>
-            </a:r>
-          </a:p>
-        </p:txBody>
-      </p:sp>
-      <p:sp>
-        <p:nvSpPr>
-          <p:cNvPr id="6" name="Rounded Rectangle 5"/>
+          <p:cNvPr id="3" name="Oval 2"/>
           <p:cNvSpPr/>
           <p:nvPr/>
         </p:nvSpPr>
         <p:spPr>
           <a:xfrm>
-            <a:off x="749808" y="4754880"/>
-            <a:ext cx="1371600" cy="64008"/>
-          </a:xfrm>
-          <a:prstGeom prst="roundRect">
-            <a:avLst/>
-          </a:prstGeom>
-          <a:solidFill>
-            <a:srgbClr val="4FC3D0"/>
-          </a:solidFill>
-          <a:ln>
-            <a:noFill/>
-          </a:ln>
-          <a:effectLst/>
-        </p:spPr>
-        <p:style>
-          <a:lnRef idx="1">
-            <a:schemeClr val="accent1"/>
-          </a:lnRef>
-          <a:fillRef idx="3">
-            <a:schemeClr val="accent1"/>
-          </a:fillRef>
-          <a:effectRef idx="2">
-            <a:schemeClr val="accent1"/>
-          </a:effectRef>
-          <a:fontRef idx="minor">
-            <a:schemeClr val="lt1"/>
-          </a:fontRef>
-        </p:style>
-        <p:txBody>
-          <a:bodyPr rtlCol="0" anchor="ctr"/>
-          <a:lstStyle/>
-          <a:p>
-            <a:pPr algn="ctr"/>
-          </a:p>
-        </p:txBody>
-      </p:sp>
-      <p:sp>
-        <p:nvSpPr>
-          <p:cNvPr id="7" name="TextBox 6"/>
-          <p:cNvSpPr txBox="1"/>
-          <p:nvPr/>
-        </p:nvSpPr>
-        <p:spPr>
-          <a:xfrm>
-            <a:off x="4434840" y="1417320"/>
-            <a:ext cx="4297680" cy="2011680"/>
-          </a:xfrm>
-          <a:prstGeom prst="rect">
-            <a:avLst/>
-          </a:prstGeom>
-          <a:noFill/>
-        </p:spPr>
-        <p:txBody>
-          <a:bodyPr wrap="square" anchor="t" lIns="0" rIns="0" tIns="0" bIns="0">
-            <a:spAutoFit/>
-          </a:bodyPr>
-          <a:lstStyle/>
-          <a:p>
-            <a:pPr algn="l">
-              <a:lnSpc>
-                <a:spcPct val="104000"/>
-              </a:lnSpc>
-            </a:pPr>
-            <a:r>
-              <a:rPr sz="3500" b="1" i="0">
-                <a:solidFill>
-                  <a:srgbClr val="004B36"/>
-                </a:solidFill>
-                <a:latin typeface="Arial"/>
-              </a:rPr>
-              <a:t>A serious scooter accident changed her life.</a:t>
-            </a:r>
-          </a:p>
-        </p:txBody>
-      </p:sp>
-      <p:sp>
-        <p:nvSpPr>
-          <p:cNvPr id="8" name="TextBox 7"/>
-          <p:cNvSpPr txBox="1"/>
-          <p:nvPr/>
-        </p:nvSpPr>
-        <p:spPr>
-          <a:xfrm>
-            <a:off x="4434840" y="3429000"/>
-            <a:ext cx="4160520" cy="868680"/>
-          </a:xfrm>
-          <a:prstGeom prst="rect">
-            <a:avLst/>
-          </a:prstGeom>
-          <a:noFill/>
-        </p:spPr>
-        <p:txBody>
-          <a:bodyPr wrap="square" anchor="t" lIns="0" rIns="0" tIns="0" bIns="0">
-            <a:spAutoFit/>
-          </a:bodyPr>
-          <a:lstStyle/>
-          <a:p>
-            <a:pPr algn="l"/>
-            <a:r>
-              <a:rPr sz="2200" b="0" i="0">
-                <a:solidFill>
-                  <a:srgbClr val="007749"/>
-                </a:solidFill>
-                <a:latin typeface="Arial"/>
-              </a:rPr>
-              <a:t>Doctors had to amputate her left leg.</a:t>
-            </a:r>
-          </a:p>
-        </p:txBody>
-      </p:sp>
-      <p:sp>
-        <p:nvSpPr>
-          <p:cNvPr id="9" name="Rounded Rectangle 8"/>
-          <p:cNvSpPr/>
-          <p:nvPr/>
-        </p:nvSpPr>
-        <p:spPr>
-          <a:xfrm>
-            <a:off x="4434840" y="4526280"/>
-            <a:ext cx="1554480" cy="530352"/>
-          </a:xfrm>
-          <a:prstGeom prst="roundRect">
-            <a:avLst/>
-          </a:prstGeom>
-          <a:solidFill>
-            <a:srgbClr val="D22630"/>
-          </a:solidFill>
-          <a:ln>
-            <a:noFill/>
-          </a:ln>
-          <a:effectLst/>
-        </p:spPr>
-        <p:style>
-          <a:lnRef idx="1">
-            <a:schemeClr val="accent1"/>
-          </a:lnRef>
-          <a:fillRef idx="3">
-            <a:schemeClr val="accent1"/>
-          </a:fillRef>
-          <a:effectRef idx="2">
-            <a:schemeClr val="accent1"/>
-          </a:effectRef>
-          <a:fontRef idx="minor">
-            <a:schemeClr val="lt1"/>
-          </a:fontRef>
-        </p:style>
-        <p:txBody>
-          <a:bodyPr rtlCol="0" anchor="ctr"/>
-          <a:lstStyle/>
-          <a:p>
-            <a:pPr algn="ctr"/>
-            <a:r>
-              <a:rPr sz="1400" b="1" spc="150">
-                <a:solidFill>
-                  <a:srgbClr val="FFFFFF"/>
-                </a:solidFill>
-                <a:latin typeface="Arial"/>
-              </a:rPr>
-              <a:t>BRAVE</a:t>
-            </a:r>
-          </a:p>
-        </p:txBody>
-      </p:sp>
-      <p:sp>
-        <p:nvSpPr>
-          <p:cNvPr id="10" name="Rounded Rectangle 9"/>
-          <p:cNvSpPr/>
-          <p:nvPr/>
-        </p:nvSpPr>
-        <p:spPr>
-          <a:xfrm>
-            <a:off x="6172200" y="4526280"/>
-            <a:ext cx="2606040" cy="530352"/>
-          </a:xfrm>
-          <a:prstGeom prst="roundRect">
+            <a:off x="8778240" y="-2651760"/>
+            <a:ext cx="5852160" cy="5852160"/>
+          </a:xfrm>
+          <a:prstGeom prst="ellipse">
             <a:avLst/>
           </a:prstGeom>
           <a:solidFill>
@@ -4913,30 +4699,492 @@
           <a:lstStyle/>
           <a:p>
             <a:pPr algn="ctr"/>
-            <a:r>
-              <a:rPr sz="1400" b="1" spc="150">
+          </a:p>
+        </p:txBody>
+      </p:sp>
+      <p:sp>
+        <p:nvSpPr>
+          <p:cNvPr id="4" name="TextBox 3"/>
+          <p:cNvSpPr txBox="1"/>
+          <p:nvPr/>
+        </p:nvSpPr>
+        <p:spPr>
+          <a:xfrm>
+            <a:off x="822960" y="1051560"/>
+            <a:ext cx="5486400" cy="384048"/>
+          </a:xfrm>
+          <a:prstGeom prst="rect">
+            <a:avLst/>
+          </a:prstGeom>
+          <a:noFill/>
+        </p:spPr>
+        <p:txBody>
+          <a:bodyPr wrap="square" anchor="t" lIns="0" rIns="0" tIns="0" bIns="0">
+            <a:spAutoFit/>
+          </a:bodyPr>
+          <a:lstStyle/>
+          <a:p>
+            <a:pPr algn="l"/>
+            <a:r>
+              <a:rPr sz="1800" b="1" i="0" spc="300">
+                <a:solidFill>
+                  <a:srgbClr val="FFB81C"/>
+                </a:solidFill>
+                <a:latin typeface="Arial"/>
+              </a:rPr>
+              <a:t>MEET MY HERO</a:t>
+            </a:r>
+          </a:p>
+        </p:txBody>
+      </p:sp>
+      <p:sp>
+        <p:nvSpPr>
+          <p:cNvPr id="5" name="TextBox 4"/>
+          <p:cNvSpPr txBox="1"/>
+          <p:nvPr/>
+        </p:nvSpPr>
+        <p:spPr>
+          <a:xfrm>
+            <a:off x="786384" y="1463040"/>
+            <a:ext cx="6035040" cy="1737360"/>
+          </a:xfrm>
+          <a:prstGeom prst="rect">
+            <a:avLst/>
+          </a:prstGeom>
+          <a:noFill/>
+        </p:spPr>
+        <p:txBody>
+          <a:bodyPr wrap="square" anchor="t" lIns="0" rIns="0" tIns="0" bIns="0">
+            <a:spAutoFit/>
+          </a:bodyPr>
+          <a:lstStyle/>
+          <a:p>
+            <a:pPr algn="l">
+              <a:lnSpc>
+                <a:spcPct val="100000"/>
+              </a:lnSpc>
+            </a:pPr>
+            <a:r>
+              <a:rPr sz="4800" b="1" i="0">
                 <a:solidFill>
                   <a:srgbClr val="FFFFFF"/>
                 </a:solidFill>
                 <a:latin typeface="Arial"/>
               </a:rPr>
-              <a:t>DID NOT GIVE UP</a:t>
-            </a:r>
-          </a:p>
-        </p:txBody>
-      </p:sp>
-      <p:sp>
-        <p:nvSpPr>
-          <p:cNvPr id="11" name="Rounded Rectangle 10"/>
+              <a:t>A swimmer from</a:t>
+            </a:r>
+          </a:p>
+          <a:p>
+            <a:pPr algn="l">
+              <a:lnSpc>
+                <a:spcPct val="100000"/>
+              </a:lnSpc>
+            </a:pPr>
+            <a:r>
+              <a:rPr sz="4800" b="1" i="0">
+                <a:solidFill>
+                  <a:srgbClr val="FFFFFF"/>
+                </a:solidFill>
+                <a:latin typeface="Arial"/>
+              </a:rPr>
+              <a:t>Cape Town</a:t>
+            </a:r>
+          </a:p>
+        </p:txBody>
+      </p:sp>
+      <p:sp>
+        <p:nvSpPr>
+          <p:cNvPr id="6" name="Oval 5"/>
           <p:cNvSpPr/>
           <p:nvPr/>
         </p:nvSpPr>
         <p:spPr>
           <a:xfrm>
-            <a:off x="8869680" y="1600200"/>
-            <a:ext cx="2743200" cy="4114800"/>
+            <a:off x="868680" y="3721607"/>
+            <a:ext cx="384048" cy="384048"/>
+          </a:xfrm>
+          <a:prstGeom prst="ellipse">
+            <a:avLst/>
+          </a:prstGeom>
+          <a:solidFill>
+            <a:srgbClr val="007749"/>
+          </a:solidFill>
+          <a:ln w="22225">
+            <a:solidFill>
+              <a:srgbClr val="FFB81C"/>
+            </a:solidFill>
+          </a:ln>
+          <a:effectLst/>
+        </p:spPr>
+        <p:style>
+          <a:lnRef idx="1">
+            <a:schemeClr val="accent1"/>
+          </a:lnRef>
+          <a:fillRef idx="3">
+            <a:schemeClr val="accent1"/>
+          </a:fillRef>
+          <a:effectRef idx="2">
+            <a:schemeClr val="accent1"/>
+          </a:effectRef>
+          <a:fontRef idx="minor">
+            <a:schemeClr val="lt1"/>
+          </a:fontRef>
+        </p:style>
+        <p:txBody>
+          <a:bodyPr rtlCol="0" anchor="ctr" tIns="0" bIns="0"/>
+          <a:lstStyle/>
+          <a:p>
+            <a:pPr algn="ctr"/>
+            <a:r>
+              <a:rPr sz="1500" b="1">
+                <a:solidFill>
+                  <a:srgbClr val="FFB81C"/>
+                </a:solidFill>
+                <a:latin typeface="Arial"/>
+              </a:rPr>
+              <a:t>★</a:t>
+            </a:r>
+          </a:p>
+        </p:txBody>
+      </p:sp>
+      <p:sp>
+        <p:nvSpPr>
+          <p:cNvPr id="7" name="TextBox 6"/>
+          <p:cNvSpPr txBox="1"/>
+          <p:nvPr/>
+        </p:nvSpPr>
+        <p:spPr>
+          <a:xfrm>
+            <a:off x="1463040" y="3730752"/>
+            <a:ext cx="5669280" cy="457200"/>
+          </a:xfrm>
+          <a:prstGeom prst="rect">
+            <a:avLst/>
+          </a:prstGeom>
+          <a:noFill/>
+        </p:spPr>
+        <p:txBody>
+          <a:bodyPr wrap="square" anchor="t" lIns="0" rIns="0" tIns="0" bIns="0">
+            <a:spAutoFit/>
+          </a:bodyPr>
+          <a:lstStyle/>
+          <a:p>
+            <a:pPr algn="l"/>
+            <a:r>
+              <a:rPr sz="2000" b="0" i="0">
+                <a:solidFill>
+                  <a:srgbClr val="FFF6E5"/>
+                </a:solidFill>
+                <a:latin typeface="Arial"/>
+              </a:rPr>
+              <a:t>Born in Cape Town</a:t>
+            </a:r>
+          </a:p>
+        </p:txBody>
+      </p:sp>
+      <p:sp>
+        <p:nvSpPr>
+          <p:cNvPr id="8" name="Oval 7"/>
+          <p:cNvSpPr/>
+          <p:nvPr/>
+        </p:nvSpPr>
+        <p:spPr>
+          <a:xfrm>
+            <a:off x="868680" y="4379975"/>
+            <a:ext cx="384048" cy="384048"/>
+          </a:xfrm>
+          <a:prstGeom prst="ellipse">
+            <a:avLst/>
+          </a:prstGeom>
+          <a:solidFill>
+            <a:srgbClr val="007749"/>
+          </a:solidFill>
+          <a:ln w="22225">
+            <a:solidFill>
+              <a:srgbClr val="FFB81C"/>
+            </a:solidFill>
+          </a:ln>
+          <a:effectLst/>
+        </p:spPr>
+        <p:style>
+          <a:lnRef idx="1">
+            <a:schemeClr val="accent1"/>
+          </a:lnRef>
+          <a:fillRef idx="3">
+            <a:schemeClr val="accent1"/>
+          </a:fillRef>
+          <a:effectRef idx="2">
+            <a:schemeClr val="accent1"/>
+          </a:effectRef>
+          <a:fontRef idx="minor">
+            <a:schemeClr val="lt1"/>
+          </a:fontRef>
+        </p:style>
+        <p:txBody>
+          <a:bodyPr rtlCol="0" anchor="ctr" tIns="0" bIns="0"/>
+          <a:lstStyle/>
+          <a:p>
+            <a:pPr algn="ctr"/>
+            <a:r>
+              <a:rPr sz="1500" b="1">
+                <a:solidFill>
+                  <a:srgbClr val="FFB81C"/>
+                </a:solidFill>
+                <a:latin typeface="Arial"/>
+              </a:rPr>
+              <a:t>≈</a:t>
+            </a:r>
+          </a:p>
+        </p:txBody>
+      </p:sp>
+      <p:sp>
+        <p:nvSpPr>
+          <p:cNvPr id="9" name="TextBox 8"/>
+          <p:cNvSpPr txBox="1"/>
+          <p:nvPr/>
+        </p:nvSpPr>
+        <p:spPr>
+          <a:xfrm>
+            <a:off x="1463040" y="4389120"/>
+            <a:ext cx="5669280" cy="457200"/>
+          </a:xfrm>
+          <a:prstGeom prst="rect">
+            <a:avLst/>
+          </a:prstGeom>
+          <a:noFill/>
+        </p:spPr>
+        <p:txBody>
+          <a:bodyPr wrap="square" anchor="t" lIns="0" rIns="0" tIns="0" bIns="0">
+            <a:spAutoFit/>
+          </a:bodyPr>
+          <a:lstStyle/>
+          <a:p>
+            <a:pPr algn="l"/>
+            <a:r>
+              <a:rPr sz="2000" b="0" i="0">
+                <a:solidFill>
+                  <a:srgbClr val="FFF6E5"/>
+                </a:solidFill>
+                <a:latin typeface="Arial"/>
+              </a:rPr>
+              <a:t>Loved swimming from a young age</a:t>
+            </a:r>
+          </a:p>
+        </p:txBody>
+      </p:sp>
+      <p:sp>
+        <p:nvSpPr>
+          <p:cNvPr id="10" name="Oval 9"/>
+          <p:cNvSpPr/>
+          <p:nvPr/>
+        </p:nvSpPr>
+        <p:spPr>
+          <a:xfrm>
+            <a:off x="868680" y="5038343"/>
+            <a:ext cx="384048" cy="384048"/>
+          </a:xfrm>
+          <a:prstGeom prst="ellipse">
+            <a:avLst/>
+          </a:prstGeom>
+          <a:solidFill>
+            <a:srgbClr val="007749"/>
+          </a:solidFill>
+          <a:ln w="22225">
+            <a:solidFill>
+              <a:srgbClr val="FFB81C"/>
+            </a:solidFill>
+          </a:ln>
+          <a:effectLst/>
+        </p:spPr>
+        <p:style>
+          <a:lnRef idx="1">
+            <a:schemeClr val="accent1"/>
+          </a:lnRef>
+          <a:fillRef idx="3">
+            <a:schemeClr val="accent1"/>
+          </a:fillRef>
+          <a:effectRef idx="2">
+            <a:schemeClr val="accent1"/>
+          </a:effectRef>
+          <a:fontRef idx="minor">
+            <a:schemeClr val="lt1"/>
+          </a:fontRef>
+        </p:style>
+        <p:txBody>
+          <a:bodyPr rtlCol="0" anchor="ctr" tIns="0" bIns="0"/>
+          <a:lstStyle/>
+          <a:p>
+            <a:pPr algn="ctr"/>
+            <a:r>
+              <a:rPr sz="1500" b="1">
+                <a:solidFill>
+                  <a:srgbClr val="FFB81C"/>
+                </a:solidFill>
+                <a:latin typeface="Arial"/>
+              </a:rPr>
+              <a:t>✓</a:t>
+            </a:r>
+          </a:p>
+        </p:txBody>
+      </p:sp>
+      <p:sp>
+        <p:nvSpPr>
+          <p:cNvPr id="11" name="TextBox 10"/>
+          <p:cNvSpPr txBox="1"/>
+          <p:nvPr/>
+        </p:nvSpPr>
+        <p:spPr>
+          <a:xfrm>
+            <a:off x="1463040" y="5047488"/>
+            <a:ext cx="5669280" cy="457200"/>
+          </a:xfrm>
+          <a:prstGeom prst="rect">
+            <a:avLst/>
+          </a:prstGeom>
+          <a:noFill/>
+        </p:spPr>
+        <p:txBody>
+          <a:bodyPr wrap="square" anchor="t" lIns="0" rIns="0" tIns="0" bIns="0">
+            <a:spAutoFit/>
+          </a:bodyPr>
+          <a:lstStyle/>
+          <a:p>
+            <a:pPr algn="l"/>
+            <a:r>
+              <a:rPr sz="2000" b="0" i="0">
+                <a:solidFill>
+                  <a:srgbClr val="FFF6E5"/>
+                </a:solidFill>
+                <a:latin typeface="Arial"/>
+              </a:rPr>
+              <a:t>Became a famous South African swimmer</a:t>
+            </a:r>
+          </a:p>
+        </p:txBody>
+      </p:sp>
+      <p:pic>
+        <p:nvPicPr>
+          <p:cNvPr id="12" name="Picture 11" descr="natalie-capetown.jpg"/>
+          <p:cNvPicPr>
+            <a:picLocks noChangeAspect="1"/>
+          </p:cNvPicPr>
+          <p:nvPr/>
+        </p:nvPicPr>
+        <p:blipFill>
+          <a:blip r:embed="rId2"/>
+          <a:stretch>
+            <a:fillRect/>
+          </a:stretch>
+        </p:blipFill>
+        <p:spPr>
+          <a:xfrm>
+            <a:off x="7269480" y="1828800"/>
+            <a:ext cx="4206240" cy="2743200"/>
           </a:xfrm>
           <a:prstGeom prst="roundRect">
+            <a:avLst>
+              <a:gd name="adj" fmla="val 9000"/>
+            </a:avLst>
+          </a:prstGeom>
+          <a:ln w="63500">
+            <a:solidFill>
+              <a:srgbClr val="FFB81C"/>
+            </a:solidFill>
+          </a:ln>
+          <a:effectLst/>
+        </p:spPr>
+      </p:pic>
+      <p:sp>
+        <p:nvSpPr>
+          <p:cNvPr id="13" name="TextBox 12"/>
+          <p:cNvSpPr txBox="1"/>
+          <p:nvPr/>
+        </p:nvSpPr>
+        <p:spPr>
+          <a:xfrm>
+            <a:off x="7269480" y="4736592"/>
+            <a:ext cx="4206240" cy="274320"/>
+          </a:xfrm>
+          <a:prstGeom prst="rect">
+            <a:avLst/>
+          </a:prstGeom>
+          <a:noFill/>
+        </p:spPr>
+        <p:txBody>
+          <a:bodyPr wrap="square" anchor="t" lIns="0" rIns="0" tIns="0" bIns="0">
+            <a:spAutoFit/>
+          </a:bodyPr>
+          <a:lstStyle/>
+          <a:p>
+            <a:pPr algn="ctr"/>
+            <a:r>
+              <a:rPr sz="1100" b="1" i="0" spc="150">
+                <a:solidFill>
+                  <a:srgbClr val="FFB81C"/>
+                </a:solidFill>
+                <a:latin typeface="Arial"/>
+              </a:rPr>
+              <a:t>TRAINING IN CAPE TOWN</a:t>
+            </a:r>
+          </a:p>
+        </p:txBody>
+      </p:sp>
+      <p:sp>
+        <p:nvSpPr>
+          <p:cNvPr id="14" name="Rectangle 13"/>
+          <p:cNvSpPr/>
+          <p:nvPr/>
+        </p:nvSpPr>
+        <p:spPr>
+          <a:xfrm>
+            <a:off x="0" y="6794500"/>
+            <a:ext cx="12191695" cy="63500"/>
+          </a:xfrm>
+          <a:prstGeom prst="rect">
+            <a:avLst/>
+          </a:prstGeom>
+          <a:solidFill>
+            <a:srgbClr val="2A4A3E"/>
+          </a:solidFill>
+          <a:ln>
+            <a:noFill/>
+          </a:ln>
+          <a:effectLst/>
+        </p:spPr>
+        <p:style>
+          <a:lnRef idx="1">
+            <a:schemeClr val="accent1"/>
+          </a:lnRef>
+          <a:fillRef idx="3">
+            <a:schemeClr val="accent1"/>
+          </a:fillRef>
+          <a:effectRef idx="2">
+            <a:schemeClr val="accent1"/>
+          </a:effectRef>
+          <a:fontRef idx="minor">
+            <a:schemeClr val="lt1"/>
+          </a:fontRef>
+        </p:style>
+        <p:txBody>
+          <a:bodyPr rtlCol="0" anchor="ctr"/>
+          <a:lstStyle/>
+          <a:p>
+            <a:pPr algn="ctr"/>
+          </a:p>
+        </p:txBody>
+      </p:sp>
+      <p:sp>
+        <p:nvSpPr>
+          <p:cNvPr id="15" name="Rectangle 14"/>
+          <p:cNvSpPr/>
+          <p:nvPr/>
+        </p:nvSpPr>
+        <p:spPr>
+          <a:xfrm>
+            <a:off x="0" y="6794500"/>
+            <a:ext cx="3483341" cy="63500"/>
+          </a:xfrm>
+          <a:prstGeom prst="rect">
             <a:avLst/>
           </a:prstGeom>
           <a:solidFill>
@@ -4969,156 +5217,6 @@
           </a:p>
         </p:txBody>
       </p:sp>
-      <p:pic>
-        <p:nvPicPr>
-          <p:cNvPr id="12" name="Picture 11" descr="natalie-positive.jpg"/>
-          <p:cNvPicPr>
-            <a:picLocks noChangeAspect="1"/>
-          </p:cNvPicPr>
-          <p:nvPr/>
-        </p:nvPicPr>
-        <p:blipFill>
-          <a:blip r:embed="rId2"/>
-          <a:stretch>
-            <a:fillRect/>
-          </a:stretch>
-        </p:blipFill>
-        <p:spPr>
-          <a:xfrm>
-            <a:off x="9070848" y="1399032"/>
-            <a:ext cx="2743200" cy="4114800"/>
-          </a:xfrm>
-          <a:effectLst/>
-          <a:prstGeom prst="roundRect">
-            <a:avLst>
-              <a:gd name="adj" fmla="val 9000"/>
-            </a:avLst>
-          </a:prstGeom>
-        </p:spPr>
-      </p:pic>
-      <p:sp>
-        <p:nvSpPr>
-          <p:cNvPr id="13" name="TextBox 12"/>
-          <p:cNvSpPr txBox="1"/>
-          <p:nvPr/>
-        </p:nvSpPr>
-        <p:spPr>
-          <a:xfrm>
-            <a:off x="8869680" y="5870448"/>
-            <a:ext cx="2944368" cy="274320"/>
-          </a:xfrm>
-          <a:prstGeom prst="rect">
-            <a:avLst/>
-          </a:prstGeom>
-          <a:noFill/>
-        </p:spPr>
-        <p:txBody>
-          <a:bodyPr wrap="square" anchor="t" lIns="0" rIns="0" tIns="0" bIns="0">
-            <a:spAutoFit/>
-          </a:bodyPr>
-          <a:lstStyle/>
-          <a:p>
-            <a:pPr algn="ctr"/>
-            <a:r>
-              <a:rPr sz="1100" b="1" i="0" spc="100">
-                <a:solidFill>
-                  <a:srgbClr val="004B36"/>
-                </a:solidFill>
-                <a:latin typeface="Arial"/>
-              </a:rPr>
-              <a:t>Natalie with her Laureus award</a:t>
-            </a:r>
-          </a:p>
-        </p:txBody>
-      </p:sp>
-      <p:sp>
-        <p:nvSpPr>
-          <p:cNvPr id="14" name="Rectangle 13"/>
-          <p:cNvSpPr/>
-          <p:nvPr/>
-        </p:nvSpPr>
-        <p:spPr>
-          <a:xfrm>
-            <a:off x="0" y="6794500"/>
-            <a:ext cx="12191695" cy="63500"/>
-          </a:xfrm>
-          <a:prstGeom prst="rect">
-            <a:avLst/>
-          </a:prstGeom>
-          <a:solidFill>
-            <a:srgbClr val="E3D9C2"/>
-          </a:solidFill>
-          <a:ln>
-            <a:noFill/>
-          </a:ln>
-          <a:effectLst/>
-        </p:spPr>
-        <p:style>
-          <a:lnRef idx="1">
-            <a:schemeClr val="accent1"/>
-          </a:lnRef>
-          <a:fillRef idx="3">
-            <a:schemeClr val="accent1"/>
-          </a:fillRef>
-          <a:effectRef idx="2">
-            <a:schemeClr val="accent1"/>
-          </a:effectRef>
-          <a:fontRef idx="minor">
-            <a:schemeClr val="lt1"/>
-          </a:fontRef>
-        </p:style>
-        <p:txBody>
-          <a:bodyPr rtlCol="0" anchor="ctr"/>
-          <a:lstStyle/>
-          <a:p>
-            <a:pPr algn="ctr"/>
-          </a:p>
-        </p:txBody>
-      </p:sp>
-      <p:sp>
-        <p:nvSpPr>
-          <p:cNvPr id="15" name="Rectangle 14"/>
-          <p:cNvSpPr/>
-          <p:nvPr/>
-        </p:nvSpPr>
-        <p:spPr>
-          <a:xfrm>
-            <a:off x="0" y="6794500"/>
-            <a:ext cx="4063898" cy="63500"/>
-          </a:xfrm>
-          <a:prstGeom prst="rect">
-            <a:avLst/>
-          </a:prstGeom>
-          <a:solidFill>
-            <a:srgbClr val="FFB81C"/>
-          </a:solidFill>
-          <a:ln>
-            <a:noFill/>
-          </a:ln>
-          <a:effectLst/>
-        </p:spPr>
-        <p:style>
-          <a:lnRef idx="1">
-            <a:schemeClr val="accent1"/>
-          </a:lnRef>
-          <a:fillRef idx="3">
-            <a:schemeClr val="accent1"/>
-          </a:fillRef>
-          <a:effectRef idx="2">
-            <a:schemeClr val="accent1"/>
-          </a:effectRef>
-          <a:fontRef idx="minor">
-            <a:schemeClr val="lt1"/>
-          </a:fontRef>
-        </p:style>
-        <p:txBody>
-          <a:bodyPr rtlCol="0" anchor="ctr"/>
-          <a:lstStyle/>
-          <a:p>
-            <a:pPr algn="ctr"/>
-          </a:p>
-        </p:txBody>
-      </p:sp>
       <p:sp>
         <p:nvSpPr>
           <p:cNvPr id="16" name="TextBox 15"/>
@@ -5154,11 +5252,11 @@
             <a:r>
               <a:rPr sz="1200" b="1" i="0" spc="200">
                 <a:solidFill>
-                  <a:srgbClr val="004B36"/>
+                  <a:srgbClr val="FFFFFF"/>
                 </a:solidFill>
                 <a:latin typeface="Arial"/>
               </a:rPr>
-              <a:t> / 06</a:t>
+              <a:t> / 07</a:t>
             </a:r>
           </a:p>
         </p:txBody>
@@ -5205,9 +5303,435 @@
         <p:nvPr/>
       </p:nvGrpSpPr>
       <p:grpSpPr/>
+      <p:sp>
+        <p:nvSpPr>
+          <p:cNvPr id="2" name="Rectangle 1"/>
+          <p:cNvSpPr/>
+          <p:nvPr/>
+        </p:nvSpPr>
+        <p:spPr>
+          <a:xfrm>
+            <a:off x="0" y="0"/>
+            <a:ext cx="12191695" cy="6858000"/>
+          </a:xfrm>
+          <a:prstGeom prst="rect">
+            <a:avLst/>
+          </a:prstGeom>
+          <a:solidFill>
+            <a:srgbClr val="FFF6E5"/>
+          </a:solidFill>
+          <a:ln>
+            <a:noFill/>
+          </a:ln>
+          <a:effectLst/>
+        </p:spPr>
+        <p:style>
+          <a:lnRef idx="1">
+            <a:schemeClr val="accent1"/>
+          </a:lnRef>
+          <a:fillRef idx="3">
+            <a:schemeClr val="accent1"/>
+          </a:fillRef>
+          <a:effectRef idx="2">
+            <a:schemeClr val="accent1"/>
+          </a:effectRef>
+          <a:fontRef idx="minor">
+            <a:schemeClr val="lt1"/>
+          </a:fontRef>
+        </p:style>
+        <p:txBody>
+          <a:bodyPr rtlCol="0" anchor="ctr"/>
+          <a:lstStyle/>
+          <a:p>
+            <a:pPr algn="ctr"/>
+          </a:p>
+        </p:txBody>
+      </p:sp>
+      <p:sp>
+        <p:nvSpPr>
+          <p:cNvPr id="3" name="Rectangle 2"/>
+          <p:cNvSpPr/>
+          <p:nvPr/>
+        </p:nvSpPr>
+        <p:spPr>
+          <a:xfrm>
+            <a:off x="0" y="0"/>
+            <a:ext cx="3977639" cy="6858000"/>
+          </a:xfrm>
+          <a:prstGeom prst="rect">
+            <a:avLst/>
+          </a:prstGeom>
+          <a:solidFill>
+            <a:srgbClr val="004B36"/>
+          </a:solidFill>
+          <a:ln>
+            <a:noFill/>
+          </a:ln>
+          <a:effectLst/>
+        </p:spPr>
+        <p:style>
+          <a:lnRef idx="1">
+            <a:schemeClr val="accent1"/>
+          </a:lnRef>
+          <a:fillRef idx="3">
+            <a:schemeClr val="accent1"/>
+          </a:fillRef>
+          <a:effectRef idx="2">
+            <a:schemeClr val="accent1"/>
+          </a:effectRef>
+          <a:fontRef idx="minor">
+            <a:schemeClr val="lt1"/>
+          </a:fontRef>
+        </p:style>
+        <p:txBody>
+          <a:bodyPr rtlCol="0" anchor="ctr"/>
+          <a:lstStyle/>
+          <a:p>
+            <a:pPr algn="ctr"/>
+          </a:p>
+        </p:txBody>
+      </p:sp>
+      <p:sp>
+        <p:nvSpPr>
+          <p:cNvPr id="4" name="TextBox 3"/>
+          <p:cNvSpPr txBox="1"/>
+          <p:nvPr/>
+        </p:nvSpPr>
+        <p:spPr>
+          <a:xfrm>
+            <a:off x="685800" y="1737360"/>
+            <a:ext cx="3017520" cy="2011680"/>
+          </a:xfrm>
+          <a:prstGeom prst="rect">
+            <a:avLst/>
+          </a:prstGeom>
+          <a:noFill/>
+        </p:spPr>
+        <p:txBody>
+          <a:bodyPr wrap="square" anchor="t" lIns="0" rIns="0" tIns="0" bIns="0">
+            <a:spAutoFit/>
+          </a:bodyPr>
+          <a:lstStyle/>
+          <a:p>
+            <a:pPr algn="l"/>
+            <a:r>
+              <a:rPr sz="15000" b="1" i="0">
+                <a:solidFill>
+                  <a:srgbClr val="FFB81C"/>
+                </a:solidFill>
+                <a:latin typeface="Arial"/>
+              </a:rPr>
+              <a:t>17</a:t>
+            </a:r>
+          </a:p>
+        </p:txBody>
+      </p:sp>
+      <p:sp>
+        <p:nvSpPr>
+          <p:cNvPr id="5" name="TextBox 4"/>
+          <p:cNvSpPr txBox="1"/>
+          <p:nvPr/>
+        </p:nvSpPr>
+        <p:spPr>
+          <a:xfrm>
+            <a:off x="749808" y="3977639"/>
+            <a:ext cx="2926080" cy="457200"/>
+          </a:xfrm>
+          <a:prstGeom prst="rect">
+            <a:avLst/>
+          </a:prstGeom>
+          <a:noFill/>
+        </p:spPr>
+        <p:txBody>
+          <a:bodyPr wrap="square" anchor="t" lIns="0" rIns="0" tIns="0" bIns="0">
+            <a:spAutoFit/>
+          </a:bodyPr>
+          <a:lstStyle/>
+          <a:p>
+            <a:pPr algn="l"/>
+            <a:r>
+              <a:rPr sz="2400" b="1" i="0" spc="400">
+                <a:solidFill>
+                  <a:srgbClr val="FFFFFF"/>
+                </a:solidFill>
+                <a:latin typeface="Arial"/>
+              </a:rPr>
+              <a:t>YEARS OLD</a:t>
+            </a:r>
+          </a:p>
+        </p:txBody>
+      </p:sp>
+      <p:sp>
+        <p:nvSpPr>
+          <p:cNvPr id="6" name="Rounded Rectangle 5"/>
+          <p:cNvSpPr/>
+          <p:nvPr/>
+        </p:nvSpPr>
+        <p:spPr>
+          <a:xfrm>
+            <a:off x="749808" y="4754880"/>
+            <a:ext cx="1371600" cy="64008"/>
+          </a:xfrm>
+          <a:prstGeom prst="roundRect">
+            <a:avLst/>
+          </a:prstGeom>
+          <a:solidFill>
+            <a:srgbClr val="4FC3D0"/>
+          </a:solidFill>
+          <a:ln>
+            <a:noFill/>
+          </a:ln>
+          <a:effectLst/>
+        </p:spPr>
+        <p:style>
+          <a:lnRef idx="1">
+            <a:schemeClr val="accent1"/>
+          </a:lnRef>
+          <a:fillRef idx="3">
+            <a:schemeClr val="accent1"/>
+          </a:fillRef>
+          <a:effectRef idx="2">
+            <a:schemeClr val="accent1"/>
+          </a:effectRef>
+          <a:fontRef idx="minor">
+            <a:schemeClr val="lt1"/>
+          </a:fontRef>
+        </p:style>
+        <p:txBody>
+          <a:bodyPr rtlCol="0" anchor="ctr"/>
+          <a:lstStyle/>
+          <a:p>
+            <a:pPr algn="ctr"/>
+          </a:p>
+        </p:txBody>
+      </p:sp>
+      <p:sp>
+        <p:nvSpPr>
+          <p:cNvPr id="7" name="TextBox 6"/>
+          <p:cNvSpPr txBox="1"/>
+          <p:nvPr/>
+        </p:nvSpPr>
+        <p:spPr>
+          <a:xfrm>
+            <a:off x="4434840" y="1417320"/>
+            <a:ext cx="4297680" cy="2011680"/>
+          </a:xfrm>
+          <a:prstGeom prst="rect">
+            <a:avLst/>
+          </a:prstGeom>
+          <a:noFill/>
+        </p:spPr>
+        <p:txBody>
+          <a:bodyPr wrap="square" anchor="t" lIns="0" rIns="0" tIns="0" bIns="0">
+            <a:spAutoFit/>
+          </a:bodyPr>
+          <a:lstStyle/>
+          <a:p>
+            <a:pPr algn="l">
+              <a:lnSpc>
+                <a:spcPct val="104000"/>
+              </a:lnSpc>
+            </a:pPr>
+            <a:r>
+              <a:rPr sz="3500" b="1" i="0">
+                <a:solidFill>
+                  <a:srgbClr val="004B36"/>
+                </a:solidFill>
+                <a:latin typeface="Arial"/>
+              </a:rPr>
+              <a:t>A serious scooter accident changed her life.</a:t>
+            </a:r>
+          </a:p>
+        </p:txBody>
+      </p:sp>
+      <p:sp>
+        <p:nvSpPr>
+          <p:cNvPr id="8" name="TextBox 7"/>
+          <p:cNvSpPr txBox="1"/>
+          <p:nvPr/>
+        </p:nvSpPr>
+        <p:spPr>
+          <a:xfrm>
+            <a:off x="4434840" y="3429000"/>
+            <a:ext cx="4160520" cy="868680"/>
+          </a:xfrm>
+          <a:prstGeom prst="rect">
+            <a:avLst/>
+          </a:prstGeom>
+          <a:noFill/>
+        </p:spPr>
+        <p:txBody>
+          <a:bodyPr wrap="square" anchor="t" lIns="0" rIns="0" tIns="0" bIns="0">
+            <a:spAutoFit/>
+          </a:bodyPr>
+          <a:lstStyle/>
+          <a:p>
+            <a:pPr algn="l"/>
+            <a:r>
+              <a:rPr sz="2200" b="0" i="0">
+                <a:solidFill>
+                  <a:srgbClr val="007749"/>
+                </a:solidFill>
+                <a:latin typeface="Arial"/>
+              </a:rPr>
+              <a:t>Doctors had to amputate her left leg.</a:t>
+            </a:r>
+          </a:p>
+        </p:txBody>
+      </p:sp>
+      <p:sp>
+        <p:nvSpPr>
+          <p:cNvPr id="9" name="Rounded Rectangle 8"/>
+          <p:cNvSpPr/>
+          <p:nvPr/>
+        </p:nvSpPr>
+        <p:spPr>
+          <a:xfrm>
+            <a:off x="4434840" y="4526280"/>
+            <a:ext cx="1554480" cy="530352"/>
+          </a:xfrm>
+          <a:prstGeom prst="roundRect">
+            <a:avLst/>
+          </a:prstGeom>
+          <a:solidFill>
+            <a:srgbClr val="D22630"/>
+          </a:solidFill>
+          <a:ln>
+            <a:noFill/>
+          </a:ln>
+          <a:effectLst/>
+        </p:spPr>
+        <p:style>
+          <a:lnRef idx="1">
+            <a:schemeClr val="accent1"/>
+          </a:lnRef>
+          <a:fillRef idx="3">
+            <a:schemeClr val="accent1"/>
+          </a:fillRef>
+          <a:effectRef idx="2">
+            <a:schemeClr val="accent1"/>
+          </a:effectRef>
+          <a:fontRef idx="minor">
+            <a:schemeClr val="lt1"/>
+          </a:fontRef>
+        </p:style>
+        <p:txBody>
+          <a:bodyPr rtlCol="0" anchor="ctr"/>
+          <a:lstStyle/>
+          <a:p>
+            <a:pPr algn="ctr"/>
+            <a:r>
+              <a:rPr sz="1400" b="1" spc="150">
+                <a:solidFill>
+                  <a:srgbClr val="FFFFFF"/>
+                </a:solidFill>
+                <a:latin typeface="Arial"/>
+              </a:rPr>
+              <a:t>BRAVE</a:t>
+            </a:r>
+          </a:p>
+        </p:txBody>
+      </p:sp>
+      <p:sp>
+        <p:nvSpPr>
+          <p:cNvPr id="10" name="Rounded Rectangle 9"/>
+          <p:cNvSpPr/>
+          <p:nvPr/>
+        </p:nvSpPr>
+        <p:spPr>
+          <a:xfrm>
+            <a:off x="6172200" y="4526280"/>
+            <a:ext cx="2606040" cy="530352"/>
+          </a:xfrm>
+          <a:prstGeom prst="roundRect">
+            <a:avLst/>
+          </a:prstGeom>
+          <a:solidFill>
+            <a:srgbClr val="007749"/>
+          </a:solidFill>
+          <a:ln>
+            <a:noFill/>
+          </a:ln>
+          <a:effectLst/>
+        </p:spPr>
+        <p:style>
+          <a:lnRef idx="1">
+            <a:schemeClr val="accent1"/>
+          </a:lnRef>
+          <a:fillRef idx="3">
+            <a:schemeClr val="accent1"/>
+          </a:fillRef>
+          <a:effectRef idx="2">
+            <a:schemeClr val="accent1"/>
+          </a:effectRef>
+          <a:fontRef idx="minor">
+            <a:schemeClr val="lt1"/>
+          </a:fontRef>
+        </p:style>
+        <p:txBody>
+          <a:bodyPr rtlCol="0" anchor="ctr"/>
+          <a:lstStyle/>
+          <a:p>
+            <a:pPr algn="ctr"/>
+            <a:r>
+              <a:rPr sz="1400" b="1" spc="150">
+                <a:solidFill>
+                  <a:srgbClr val="FFFFFF"/>
+                </a:solidFill>
+                <a:latin typeface="Arial"/>
+              </a:rPr>
+              <a:t>DID NOT GIVE UP</a:t>
+            </a:r>
+          </a:p>
+        </p:txBody>
+      </p:sp>
+      <p:sp>
+        <p:nvSpPr>
+          <p:cNvPr id="11" name="Rounded Rectangle 10"/>
+          <p:cNvSpPr/>
+          <p:nvPr/>
+        </p:nvSpPr>
+        <p:spPr>
+          <a:xfrm>
+            <a:off x="8869680" y="1600200"/>
+            <a:ext cx="2743200" cy="4114800"/>
+          </a:xfrm>
+          <a:prstGeom prst="roundRect">
+            <a:avLst/>
+          </a:prstGeom>
+          <a:solidFill>
+            <a:srgbClr val="FFB81C"/>
+          </a:solidFill>
+          <a:ln>
+            <a:noFill/>
+          </a:ln>
+          <a:effectLst/>
+        </p:spPr>
+        <p:style>
+          <a:lnRef idx="1">
+            <a:schemeClr val="accent1"/>
+          </a:lnRef>
+          <a:fillRef idx="3">
+            <a:schemeClr val="accent1"/>
+          </a:fillRef>
+          <a:effectRef idx="2">
+            <a:schemeClr val="accent1"/>
+          </a:effectRef>
+          <a:fontRef idx="minor">
+            <a:schemeClr val="lt1"/>
+          </a:fontRef>
+        </p:style>
+        <p:txBody>
+          <a:bodyPr rtlCol="0" anchor="ctr"/>
+          <a:lstStyle/>
+          <a:p>
+            <a:pPr algn="ctr"/>
+          </a:p>
+        </p:txBody>
+      </p:sp>
       <p:pic>
         <p:nvPicPr>
-          <p:cNvPr id="2" name="Picture 1" descr="natalie-swimming-shaded.jpg"/>
+          <p:cNvPr id="12" name="Picture 11" descr="natalie-positive.jpg"/>
           <p:cNvPicPr>
             <a:picLocks noChangeAspect="1"/>
           </p:cNvPicPr>
@@ -5221,24 +5745,27 @@
         </p:blipFill>
         <p:spPr>
           <a:xfrm>
-            <a:off x="0" y="0"/>
-            <a:ext cx="12191695" cy="6858000"/>
-          </a:xfrm>
-          <a:prstGeom prst="rect">
-            <a:avLst/>
+            <a:off x="9070848" y="1399032"/>
+            <a:ext cx="2743200" cy="4114800"/>
+          </a:xfrm>
+          <a:effectLst/>
+          <a:prstGeom prst="roundRect">
+            <a:avLst>
+              <a:gd name="adj" fmla="val 9000"/>
+            </a:avLst>
           </a:prstGeom>
         </p:spPr>
       </p:pic>
       <p:sp>
         <p:nvSpPr>
-          <p:cNvPr id="3" name="TextBox 2"/>
+          <p:cNvPr id="13" name="TextBox 12"/>
           <p:cNvSpPr txBox="1"/>
           <p:nvPr/>
         </p:nvSpPr>
         <p:spPr>
           <a:xfrm>
-            <a:off x="822960" y="1783080"/>
-            <a:ext cx="5486400" cy="384048"/>
+            <a:off x="8869680" y="5870448"/>
+            <a:ext cx="2944368" cy="274320"/>
           </a:xfrm>
           <a:prstGeom prst="rect">
             <a:avLst/>
@@ -5251,132 +5778,22 @@
           </a:bodyPr>
           <a:lstStyle/>
           <a:p>
-            <a:pPr algn="l"/>
-            <a:r>
-              <a:rPr sz="1800" b="1" i="0" spc="300">
+            <a:pPr algn="ctr"/>
+            <a:r>
+              <a:rPr sz="1100" b="1" i="0" spc="100">
                 <a:solidFill>
-                  <a:srgbClr val="FFB81C"/>
+                  <a:srgbClr val="004B36"/>
                 </a:solidFill>
                 <a:latin typeface="Arial"/>
               </a:rPr>
-              <a:t>COURAGE IN ACTION</a:t>
-            </a:r>
-          </a:p>
-        </p:txBody>
-      </p:sp>
-      <p:sp>
-        <p:nvSpPr>
-          <p:cNvPr id="4" name="TextBox 3"/>
-          <p:cNvSpPr txBox="1"/>
-          <p:nvPr/>
-        </p:nvSpPr>
-        <p:spPr>
-          <a:xfrm>
-            <a:off x="786384" y="2194560"/>
-            <a:ext cx="6766560" cy="1737360"/>
-          </a:xfrm>
-          <a:prstGeom prst="rect">
-            <a:avLst/>
-          </a:prstGeom>
-          <a:noFill/>
-        </p:spPr>
-        <p:txBody>
-          <a:bodyPr wrap="square" anchor="t" lIns="0" rIns="0" tIns="0" bIns="0">
-            <a:spAutoFit/>
-          </a:bodyPr>
-          <a:lstStyle/>
-          <a:p>
-            <a:pPr algn="l">
-              <a:lnSpc>
-                <a:spcPct val="98000"/>
-              </a:lnSpc>
-            </a:pPr>
-            <a:r>
-              <a:rPr sz="5400" b="1" i="0">
-                <a:solidFill>
-                  <a:srgbClr val="FFFFFF"/>
-                </a:solidFill>
-                <a:latin typeface="Arial"/>
-              </a:rPr>
-              <a:t>She chose to</a:t>
-            </a:r>
-          </a:p>
-          <a:p>
-            <a:pPr algn="l">
-              <a:lnSpc>
-                <a:spcPct val="98000"/>
-              </a:lnSpc>
-            </a:pPr>
-            <a:r>
-              <a:rPr sz="5400" b="1" i="0">
-                <a:solidFill>
-                  <a:srgbClr val="FFFFFF"/>
-                </a:solidFill>
-                <a:latin typeface="Arial"/>
-              </a:rPr>
-              <a:t>start again.</a:t>
-            </a:r>
-          </a:p>
-        </p:txBody>
-      </p:sp>
-      <p:sp>
-        <p:nvSpPr>
-          <p:cNvPr id="5" name="TextBox 4"/>
-          <p:cNvSpPr txBox="1"/>
-          <p:nvPr/>
-        </p:nvSpPr>
-        <p:spPr>
-          <a:xfrm>
-            <a:off x="822960" y="4160520"/>
-            <a:ext cx="5852160" cy="1097280"/>
-          </a:xfrm>
-          <a:prstGeom prst="rect">
-            <a:avLst/>
-          </a:prstGeom>
-          <a:noFill/>
-        </p:spPr>
-        <p:txBody>
-          <a:bodyPr wrap="square" anchor="t" lIns="0" rIns="0" tIns="0" bIns="0">
-            <a:spAutoFit/>
-          </a:bodyPr>
-          <a:lstStyle/>
-          <a:p>
-            <a:pPr algn="l">
-              <a:lnSpc>
-                <a:spcPct val="125000"/>
-              </a:lnSpc>
-            </a:pPr>
-            <a:r>
-              <a:rPr sz="2400" b="0" i="0">
-                <a:solidFill>
-                  <a:srgbClr val="FFFFFF"/>
-                </a:solidFill>
-                <a:latin typeface="Arial"/>
-              </a:rPr>
-              <a:t>She worked hard every day</a:t>
-            </a:r>
-          </a:p>
-          <a:p>
-            <a:pPr algn="l">
-              <a:lnSpc>
-                <a:spcPct val="125000"/>
-              </a:lnSpc>
-            </a:pPr>
-            <a:r>
-              <a:rPr sz="2400" b="0" i="0">
-                <a:solidFill>
-                  <a:srgbClr val="FFFFFF"/>
-                </a:solidFill>
-                <a:latin typeface="Arial"/>
-              </a:rPr>
-              <a:t>and returned to the pool.</a:t>
-            </a:r>
-          </a:p>
-        </p:txBody>
-      </p:sp>
-      <p:sp>
-        <p:nvSpPr>
-          <p:cNvPr id="6" name="Rectangle 5"/>
+              <a:t>Natalie with her Laureus award</a:t>
+            </a:r>
+          </a:p>
+        </p:txBody>
+      </p:sp>
+      <p:sp>
+        <p:nvSpPr>
+          <p:cNvPr id="14" name="Rectangle 13"/>
           <p:cNvSpPr/>
           <p:nvPr/>
         </p:nvSpPr>
@@ -5389,7 +5806,7 @@
             <a:avLst/>
           </a:prstGeom>
           <a:solidFill>
-            <a:srgbClr val="2A4A3E"/>
+            <a:srgbClr val="E3D9C2"/>
           </a:solidFill>
           <a:ln>
             <a:noFill/>
@@ -5420,14 +5837,14 @@
       </p:sp>
       <p:sp>
         <p:nvSpPr>
-          <p:cNvPr id="7" name="Rectangle 6"/>
+          <p:cNvPr id="15" name="Rectangle 14"/>
           <p:cNvSpPr/>
           <p:nvPr/>
         </p:nvSpPr>
         <p:spPr>
           <a:xfrm>
             <a:off x="0" y="6794500"/>
-            <a:ext cx="6095847" cy="63500"/>
+            <a:ext cx="5225012" cy="63500"/>
           </a:xfrm>
           <a:prstGeom prst="rect">
             <a:avLst/>
@@ -5464,7 +5881,7 @@
       </p:sp>
       <p:sp>
         <p:nvSpPr>
-          <p:cNvPr id="8" name="TextBox 7"/>
+          <p:cNvPr id="16" name="TextBox 15"/>
           <p:cNvSpPr txBox="1"/>
           <p:nvPr/>
         </p:nvSpPr>
@@ -5497,18 +5914,18 @@
             <a:r>
               <a:rPr sz="1200" b="1" i="0" spc="200">
                 <a:solidFill>
-                  <a:srgbClr val="FFFFFF"/>
+                  <a:srgbClr val="004B36"/>
                 </a:solidFill>
                 <a:latin typeface="Arial"/>
               </a:rPr>
-              <a:t> / 06</a:t>
+              <a:t> / 07</a:t>
             </a:r>
           </a:p>
         </p:txBody>
       </p:sp>
       <p:pic>
         <p:nvPicPr>
-          <p:cNvPr id="9" name="Picture 8" descr="panorama-crest.png"/>
+          <p:cNvPr id="17" name="Picture 16" descr="panorama-crest.png"/>
           <p:cNvPicPr>
             <a:picLocks noChangeAspect="1"/>
           </p:cNvPicPr>
@@ -5548,12 +5965,20 @@
         <p:nvPr/>
       </p:nvGrpSpPr>
       <p:grpSpPr/>
-      <p:sp>
-        <p:nvSpPr>
-          <p:cNvPr id="2" name="Rectangle 1"/>
-          <p:cNvSpPr/>
-          <p:nvPr/>
-        </p:nvSpPr>
+      <p:pic>
+        <p:nvPicPr>
+          <p:cNvPr id="2" name="Picture 1" descr="natalie-swimming-shaded.jpg"/>
+          <p:cNvPicPr>
+            <a:picLocks noChangeAspect="1"/>
+          </p:cNvPicPr>
+          <p:nvPr/>
+        </p:nvPicPr>
+        <p:blipFill>
+          <a:blip r:embed="rId2"/>
+          <a:stretch>
+            <a:fillRect/>
+          </a:stretch>
+        </p:blipFill>
         <p:spPr>
           <a:xfrm>
             <a:off x="0" y="0"/>
@@ -5562,8 +5987,169 @@
           <a:prstGeom prst="rect">
             <a:avLst/>
           </a:prstGeom>
+        </p:spPr>
+      </p:pic>
+      <p:sp>
+        <p:nvSpPr>
+          <p:cNvPr id="3" name="TextBox 2"/>
+          <p:cNvSpPr txBox="1"/>
+          <p:nvPr/>
+        </p:nvSpPr>
+        <p:spPr>
+          <a:xfrm>
+            <a:off x="822960" y="1783080"/>
+            <a:ext cx="5486400" cy="384048"/>
+          </a:xfrm>
+          <a:prstGeom prst="rect">
+            <a:avLst/>
+          </a:prstGeom>
+          <a:noFill/>
+        </p:spPr>
+        <p:txBody>
+          <a:bodyPr wrap="square" anchor="t" lIns="0" rIns="0" tIns="0" bIns="0">
+            <a:spAutoFit/>
+          </a:bodyPr>
+          <a:lstStyle/>
+          <a:p>
+            <a:pPr algn="l"/>
+            <a:r>
+              <a:rPr sz="1800" b="1" i="0" spc="300">
+                <a:solidFill>
+                  <a:srgbClr val="FFB81C"/>
+                </a:solidFill>
+                <a:latin typeface="Arial"/>
+              </a:rPr>
+              <a:t>COURAGE IN ACTION</a:t>
+            </a:r>
+          </a:p>
+        </p:txBody>
+      </p:sp>
+      <p:sp>
+        <p:nvSpPr>
+          <p:cNvPr id="4" name="TextBox 3"/>
+          <p:cNvSpPr txBox="1"/>
+          <p:nvPr/>
+        </p:nvSpPr>
+        <p:spPr>
+          <a:xfrm>
+            <a:off x="786384" y="2194560"/>
+            <a:ext cx="6766560" cy="1737360"/>
+          </a:xfrm>
+          <a:prstGeom prst="rect">
+            <a:avLst/>
+          </a:prstGeom>
+          <a:noFill/>
+        </p:spPr>
+        <p:txBody>
+          <a:bodyPr wrap="square" anchor="t" lIns="0" rIns="0" tIns="0" bIns="0">
+            <a:spAutoFit/>
+          </a:bodyPr>
+          <a:lstStyle/>
+          <a:p>
+            <a:pPr algn="l">
+              <a:lnSpc>
+                <a:spcPct val="98000"/>
+              </a:lnSpc>
+            </a:pPr>
+            <a:r>
+              <a:rPr sz="5400" b="1" i="0">
+                <a:solidFill>
+                  <a:srgbClr val="FFFFFF"/>
+                </a:solidFill>
+                <a:latin typeface="Arial"/>
+              </a:rPr>
+              <a:t>She chose to</a:t>
+            </a:r>
+          </a:p>
+          <a:p>
+            <a:pPr algn="l">
+              <a:lnSpc>
+                <a:spcPct val="98000"/>
+              </a:lnSpc>
+            </a:pPr>
+            <a:r>
+              <a:rPr sz="5400" b="1" i="0">
+                <a:solidFill>
+                  <a:srgbClr val="FFFFFF"/>
+                </a:solidFill>
+                <a:latin typeface="Arial"/>
+              </a:rPr>
+              <a:t>start again.</a:t>
+            </a:r>
+          </a:p>
+        </p:txBody>
+      </p:sp>
+      <p:sp>
+        <p:nvSpPr>
+          <p:cNvPr id="5" name="TextBox 4"/>
+          <p:cNvSpPr txBox="1"/>
+          <p:nvPr/>
+        </p:nvSpPr>
+        <p:spPr>
+          <a:xfrm>
+            <a:off x="822960" y="4160520"/>
+            <a:ext cx="5852160" cy="1097280"/>
+          </a:xfrm>
+          <a:prstGeom prst="rect">
+            <a:avLst/>
+          </a:prstGeom>
+          <a:noFill/>
+        </p:spPr>
+        <p:txBody>
+          <a:bodyPr wrap="square" anchor="t" lIns="0" rIns="0" tIns="0" bIns="0">
+            <a:spAutoFit/>
+          </a:bodyPr>
+          <a:lstStyle/>
+          <a:p>
+            <a:pPr algn="l">
+              <a:lnSpc>
+                <a:spcPct val="125000"/>
+              </a:lnSpc>
+            </a:pPr>
+            <a:r>
+              <a:rPr sz="2400" b="0" i="0">
+                <a:solidFill>
+                  <a:srgbClr val="FFFFFF"/>
+                </a:solidFill>
+                <a:latin typeface="Arial"/>
+              </a:rPr>
+              <a:t>She worked hard every day</a:t>
+            </a:r>
+          </a:p>
+          <a:p>
+            <a:pPr algn="l">
+              <a:lnSpc>
+                <a:spcPct val="125000"/>
+              </a:lnSpc>
+            </a:pPr>
+            <a:r>
+              <a:rPr sz="2400" b="0" i="0">
+                <a:solidFill>
+                  <a:srgbClr val="FFFFFF"/>
+                </a:solidFill>
+                <a:latin typeface="Arial"/>
+              </a:rPr>
+              <a:t>and returned to the pool.</a:t>
+            </a:r>
+          </a:p>
+        </p:txBody>
+      </p:sp>
+      <p:sp>
+        <p:nvSpPr>
+          <p:cNvPr id="6" name="Rectangle 5"/>
+          <p:cNvSpPr/>
+          <p:nvPr/>
+        </p:nvSpPr>
+        <p:spPr>
+          <a:xfrm>
+            <a:off x="0" y="6794500"/>
+            <a:ext cx="12191695" cy="63500"/>
+          </a:xfrm>
+          <a:prstGeom prst="rect">
+            <a:avLst/>
+          </a:prstGeom>
           <a:solidFill>
-            <a:srgbClr val="004B36"/>
+            <a:srgbClr val="2A4A3E"/>
           </a:solidFill>
           <a:ln>
             <a:noFill/>
@@ -5594,165 +6180,16 @@
       </p:sp>
       <p:sp>
         <p:nvSpPr>
-          <p:cNvPr id="3" name="Oval 2"/>
+          <p:cNvPr id="7" name="Rectangle 6"/>
           <p:cNvSpPr/>
           <p:nvPr/>
         </p:nvSpPr>
         <p:spPr>
           <a:xfrm>
-            <a:off x="-2011680" y="4206240"/>
-            <a:ext cx="5669280" cy="5669280"/>
-          </a:xfrm>
-          <a:prstGeom prst="ellipse">
-            <a:avLst/>
-          </a:prstGeom>
-          <a:solidFill>
-            <a:srgbClr val="007749"/>
-          </a:solidFill>
-          <a:ln>
-            <a:noFill/>
-          </a:ln>
-          <a:effectLst/>
-        </p:spPr>
-        <p:style>
-          <a:lnRef idx="1">
-            <a:schemeClr val="accent1"/>
-          </a:lnRef>
-          <a:fillRef idx="3">
-            <a:schemeClr val="accent1"/>
-          </a:fillRef>
-          <a:effectRef idx="2">
-            <a:schemeClr val="accent1"/>
-          </a:effectRef>
-          <a:fontRef idx="minor">
-            <a:schemeClr val="lt1"/>
-          </a:fontRef>
-        </p:style>
-        <p:txBody>
-          <a:bodyPr rtlCol="0" anchor="ctr"/>
-          <a:lstStyle/>
-          <a:p>
-            <a:pPr algn="ctr"/>
-          </a:p>
-        </p:txBody>
-      </p:sp>
-      <p:sp>
-        <p:nvSpPr>
-          <p:cNvPr id="4" name="TextBox 3"/>
-          <p:cNvSpPr txBox="1"/>
-          <p:nvPr/>
-        </p:nvSpPr>
-        <p:spPr>
-          <a:xfrm>
-            <a:off x="777240" y="914400"/>
-            <a:ext cx="5852160" cy="1737360"/>
-          </a:xfrm>
-          <a:prstGeom prst="rect">
-            <a:avLst/>
-          </a:prstGeom>
-          <a:noFill/>
-        </p:spPr>
-        <p:txBody>
-          <a:bodyPr wrap="square" anchor="t" lIns="0" rIns="0" tIns="0" bIns="0">
-            <a:spAutoFit/>
-          </a:bodyPr>
-          <a:lstStyle/>
-          <a:p>
-            <a:pPr algn="l"/>
-            <a:r>
-              <a:rPr sz="12000" b="1" i="0">
-                <a:solidFill>
-                  <a:srgbClr val="FFB81C"/>
-                </a:solidFill>
-                <a:latin typeface="Arial"/>
-              </a:rPr>
-              <a:t>2008</a:t>
-            </a:r>
-          </a:p>
-        </p:txBody>
-      </p:sp>
-      <p:sp>
-        <p:nvSpPr>
-          <p:cNvPr id="5" name="TextBox 4"/>
-          <p:cNvSpPr txBox="1"/>
-          <p:nvPr/>
-        </p:nvSpPr>
-        <p:spPr>
-          <a:xfrm>
-            <a:off x="822960" y="2834640"/>
-            <a:ext cx="6035040" cy="731520"/>
-          </a:xfrm>
-          <a:prstGeom prst="rect">
-            <a:avLst/>
-          </a:prstGeom>
-          <a:noFill/>
-        </p:spPr>
-        <p:txBody>
-          <a:bodyPr wrap="square" anchor="t" lIns="0" rIns="0" tIns="0" bIns="0">
-            <a:spAutoFit/>
-          </a:bodyPr>
-          <a:lstStyle/>
-          <a:p>
-            <a:pPr algn="l"/>
-            <a:r>
-              <a:rPr sz="4000" b="1" i="0" spc="200">
-                <a:solidFill>
-                  <a:srgbClr val="FFFFFF"/>
-                </a:solidFill>
-                <a:latin typeface="Arial"/>
-              </a:rPr>
-              <a:t>OLYMPIC GAMES</a:t>
-            </a:r>
-          </a:p>
-        </p:txBody>
-      </p:sp>
-      <p:sp>
-        <p:nvSpPr>
-          <p:cNvPr id="6" name="TextBox 5"/>
-          <p:cNvSpPr txBox="1"/>
-          <p:nvPr/>
-        </p:nvSpPr>
-        <p:spPr>
-          <a:xfrm>
-            <a:off x="822960" y="3520440"/>
-            <a:ext cx="5486400" cy="457200"/>
-          </a:xfrm>
-          <a:prstGeom prst="rect">
-            <a:avLst/>
-          </a:prstGeom>
-          <a:noFill/>
-        </p:spPr>
-        <p:txBody>
-          <a:bodyPr wrap="square" anchor="t" lIns="0" rIns="0" tIns="0" bIns="0">
-            <a:spAutoFit/>
-          </a:bodyPr>
-          <a:lstStyle/>
-          <a:p>
-            <a:pPr algn="l"/>
-            <a:r>
-              <a:rPr sz="2200" b="1" i="0" spc="600">
-                <a:solidFill>
-                  <a:srgbClr val="4FC3D0"/>
-                </a:solidFill>
-                <a:latin typeface="Arial"/>
-              </a:rPr>
-              <a:t>BEIJING</a:t>
-            </a:r>
-          </a:p>
-        </p:txBody>
-      </p:sp>
-      <p:sp>
-        <p:nvSpPr>
-          <p:cNvPr id="7" name="Rounded Rectangle 6"/>
-          <p:cNvSpPr/>
-          <p:nvPr/>
-        </p:nvSpPr>
-        <p:spPr>
-          <a:xfrm>
-            <a:off x="868680" y="4206240"/>
-            <a:ext cx="1051560" cy="68580"/>
-          </a:xfrm>
-          <a:prstGeom prst="roundRect">
+            <a:off x="0" y="6794500"/>
+            <a:ext cx="6966682" cy="63500"/>
+          </a:xfrm>
+          <a:prstGeom prst="rect">
             <a:avLst/>
           </a:prstGeom>
           <a:solidFill>
@@ -5793,216 +6230,6 @@
         </p:nvSpPr>
         <p:spPr>
           <a:xfrm>
-            <a:off x="822960" y="4526280"/>
-            <a:ext cx="6217920" cy="1097280"/>
-          </a:xfrm>
-          <a:prstGeom prst="rect">
-            <a:avLst/>
-          </a:prstGeom>
-          <a:noFill/>
-        </p:spPr>
-        <p:txBody>
-          <a:bodyPr wrap="square" anchor="t" lIns="0" rIns="0" tIns="0" bIns="0">
-            <a:spAutoFit/>
-          </a:bodyPr>
-          <a:lstStyle/>
-          <a:p>
-            <a:pPr algn="l">
-              <a:lnSpc>
-                <a:spcPct val="110000"/>
-              </a:lnSpc>
-            </a:pPr>
-            <a:r>
-              <a:rPr sz="3000" b="0" i="0">
-                <a:solidFill>
-                  <a:srgbClr val="FFFFFF"/>
-                </a:solidFill>
-                <a:latin typeface="Arial"/>
-              </a:rPr>
-              <a:t>She represented </a:t>
-            </a:r>
-          </a:p>
-          <a:p>
-            <a:pPr algn="l">
-              <a:lnSpc>
-                <a:spcPct val="110000"/>
-              </a:lnSpc>
-            </a:pPr>
-            <a:r>
-              <a:rPr sz="3000" b="1" i="0">
-                <a:solidFill>
-                  <a:srgbClr val="FFB81C"/>
-                </a:solidFill>
-                <a:latin typeface="Arial"/>
-              </a:rPr>
-              <a:t>South Africa.</a:t>
-            </a:r>
-          </a:p>
-        </p:txBody>
-      </p:sp>
-      <p:pic>
-        <p:nvPicPr>
-          <p:cNvPr id="9" name="Picture 8" descr="natalie-beijing.jpg"/>
-          <p:cNvPicPr>
-            <a:picLocks noChangeAspect="1"/>
-          </p:cNvPicPr>
-          <p:nvPr/>
-        </p:nvPicPr>
-        <p:blipFill>
-          <a:blip r:embed="rId2"/>
-          <a:stretch>
-            <a:fillRect/>
-          </a:stretch>
-        </p:blipFill>
-        <p:spPr>
-          <a:xfrm>
-            <a:off x="8366760" y="1234440"/>
-            <a:ext cx="3108960" cy="3749039"/>
-          </a:xfrm>
-          <a:prstGeom prst="roundRect">
-            <a:avLst>
-              <a:gd name="adj" fmla="val 9000"/>
-            </a:avLst>
-          </a:prstGeom>
-          <a:ln w="63500">
-            <a:solidFill>
-              <a:srgbClr val="FFB81C"/>
-            </a:solidFill>
-          </a:ln>
-          <a:effectLst/>
-        </p:spPr>
-      </p:pic>
-      <p:sp>
-        <p:nvSpPr>
-          <p:cNvPr id="10" name="TextBox 9"/>
-          <p:cNvSpPr txBox="1"/>
-          <p:nvPr/>
-        </p:nvSpPr>
-        <p:spPr>
-          <a:xfrm>
-            <a:off x="8366760" y="5138928"/>
-            <a:ext cx="3108960" cy="274320"/>
-          </a:xfrm>
-          <a:prstGeom prst="rect">
-            <a:avLst/>
-          </a:prstGeom>
-          <a:noFill/>
-        </p:spPr>
-        <p:txBody>
-          <a:bodyPr wrap="square" anchor="t" lIns="0" rIns="0" tIns="0" bIns="0">
-            <a:spAutoFit/>
-          </a:bodyPr>
-          <a:lstStyle/>
-          <a:p>
-            <a:pPr algn="ctr"/>
-            <a:r>
-              <a:rPr sz="1100" b="1" i="0" spc="150">
-                <a:solidFill>
-                  <a:srgbClr val="FFB81C"/>
-                </a:solidFill>
-                <a:latin typeface="Arial"/>
-              </a:rPr>
-              <a:t>BEIJING 2008  •  GOLD MEDAL</a:t>
-            </a:r>
-          </a:p>
-        </p:txBody>
-      </p:sp>
-      <p:sp>
-        <p:nvSpPr>
-          <p:cNvPr id="11" name="Rectangle 10"/>
-          <p:cNvSpPr/>
-          <p:nvPr/>
-        </p:nvSpPr>
-        <p:spPr>
-          <a:xfrm>
-            <a:off x="0" y="6794500"/>
-            <a:ext cx="12191695" cy="63500"/>
-          </a:xfrm>
-          <a:prstGeom prst="rect">
-            <a:avLst/>
-          </a:prstGeom>
-          <a:solidFill>
-            <a:srgbClr val="2A4A3E"/>
-          </a:solidFill>
-          <a:ln>
-            <a:noFill/>
-          </a:ln>
-          <a:effectLst/>
-        </p:spPr>
-        <p:style>
-          <a:lnRef idx="1">
-            <a:schemeClr val="accent1"/>
-          </a:lnRef>
-          <a:fillRef idx="3">
-            <a:schemeClr val="accent1"/>
-          </a:fillRef>
-          <a:effectRef idx="2">
-            <a:schemeClr val="accent1"/>
-          </a:effectRef>
-          <a:fontRef idx="minor">
-            <a:schemeClr val="lt1"/>
-          </a:fontRef>
-        </p:style>
-        <p:txBody>
-          <a:bodyPr rtlCol="0" anchor="ctr"/>
-          <a:lstStyle/>
-          <a:p>
-            <a:pPr algn="ctr"/>
-          </a:p>
-        </p:txBody>
-      </p:sp>
-      <p:sp>
-        <p:nvSpPr>
-          <p:cNvPr id="12" name="Rectangle 11"/>
-          <p:cNvSpPr/>
-          <p:nvPr/>
-        </p:nvSpPr>
-        <p:spPr>
-          <a:xfrm>
-            <a:off x="0" y="6794500"/>
-            <a:ext cx="8127796" cy="63500"/>
-          </a:xfrm>
-          <a:prstGeom prst="rect">
-            <a:avLst/>
-          </a:prstGeom>
-          <a:solidFill>
-            <a:srgbClr val="FFB81C"/>
-          </a:solidFill>
-          <a:ln>
-            <a:noFill/>
-          </a:ln>
-          <a:effectLst/>
-        </p:spPr>
-        <p:style>
-          <a:lnRef idx="1">
-            <a:schemeClr val="accent1"/>
-          </a:lnRef>
-          <a:fillRef idx="3">
-            <a:schemeClr val="accent1"/>
-          </a:fillRef>
-          <a:effectRef idx="2">
-            <a:schemeClr val="accent1"/>
-          </a:effectRef>
-          <a:fontRef idx="minor">
-            <a:schemeClr val="lt1"/>
-          </a:fontRef>
-        </p:style>
-        <p:txBody>
-          <a:bodyPr rtlCol="0" anchor="ctr"/>
-          <a:lstStyle/>
-          <a:p>
-            <a:pPr algn="ctr"/>
-          </a:p>
-        </p:txBody>
-      </p:sp>
-      <p:sp>
-        <p:nvSpPr>
-          <p:cNvPr id="13" name="TextBox 12"/>
-          <p:cNvSpPr txBox="1"/>
-          <p:nvPr/>
-        </p:nvSpPr>
-        <p:spPr>
-          <a:xfrm>
             <a:off x="10637215" y="6382512"/>
             <a:ext cx="1143000" cy="274320"/>
           </a:xfrm>
@@ -6034,14 +6261,14 @@
                 </a:solidFill>
                 <a:latin typeface="Arial"/>
               </a:rPr>
-              <a:t> / 06</a:t>
+              <a:t> / 07</a:t>
             </a:r>
           </a:p>
         </p:txBody>
       </p:sp>
       <p:pic>
         <p:nvPicPr>
-          <p:cNvPr id="14" name="Picture 13" descr="panorama-crest.png"/>
+          <p:cNvPr id="9" name="Picture 8" descr="panorama-crest.png"/>
           <p:cNvPicPr>
             <a:picLocks noChangeAspect="1"/>
           </p:cNvPicPr>
@@ -6096,7 +6323,7 @@
             <a:avLst/>
           </a:prstGeom>
           <a:solidFill>
-            <a:srgbClr val="FFF6E5"/>
+            <a:srgbClr val="004B36"/>
           </a:solidFill>
           <a:ln>
             <a:noFill/>
@@ -6127,16 +6354,16 @@
       </p:sp>
       <p:sp>
         <p:nvSpPr>
-          <p:cNvPr id="3" name="Rectangle 2"/>
+          <p:cNvPr id="3" name="Oval 2"/>
           <p:cNvSpPr/>
           <p:nvPr/>
         </p:nvSpPr>
         <p:spPr>
           <a:xfrm>
-            <a:off x="12027103" y="0"/>
-            <a:ext cx="164592" cy="6858000"/>
-          </a:xfrm>
-          <a:prstGeom prst="rect">
+            <a:off x="-2011680" y="4206240"/>
+            <a:ext cx="5669280" cy="5669280"/>
+          </a:xfrm>
+          <a:prstGeom prst="ellipse">
             <a:avLst/>
           </a:prstGeom>
           <a:solidFill>
@@ -6171,14 +6398,119 @@
       </p:sp>
       <p:sp>
         <p:nvSpPr>
-          <p:cNvPr id="4" name="Rounded Rectangle 3"/>
+          <p:cNvPr id="4" name="TextBox 3"/>
+          <p:cNvSpPr txBox="1"/>
+          <p:nvPr/>
+        </p:nvSpPr>
+        <p:spPr>
+          <a:xfrm>
+            <a:off x="777240" y="914400"/>
+            <a:ext cx="5852160" cy="1737360"/>
+          </a:xfrm>
+          <a:prstGeom prst="rect">
+            <a:avLst/>
+          </a:prstGeom>
+          <a:noFill/>
+        </p:spPr>
+        <p:txBody>
+          <a:bodyPr wrap="square" anchor="t" lIns="0" rIns="0" tIns="0" bIns="0">
+            <a:spAutoFit/>
+          </a:bodyPr>
+          <a:lstStyle/>
+          <a:p>
+            <a:pPr algn="l"/>
+            <a:r>
+              <a:rPr sz="12000" b="1" i="0">
+                <a:solidFill>
+                  <a:srgbClr val="FFB81C"/>
+                </a:solidFill>
+                <a:latin typeface="Arial"/>
+              </a:rPr>
+              <a:t>2008</a:t>
+            </a:r>
+          </a:p>
+        </p:txBody>
+      </p:sp>
+      <p:sp>
+        <p:nvSpPr>
+          <p:cNvPr id="5" name="TextBox 4"/>
+          <p:cNvSpPr txBox="1"/>
+          <p:nvPr/>
+        </p:nvSpPr>
+        <p:spPr>
+          <a:xfrm>
+            <a:off x="822960" y="2834640"/>
+            <a:ext cx="6035040" cy="731520"/>
+          </a:xfrm>
+          <a:prstGeom prst="rect">
+            <a:avLst/>
+          </a:prstGeom>
+          <a:noFill/>
+        </p:spPr>
+        <p:txBody>
+          <a:bodyPr wrap="square" anchor="t" lIns="0" rIns="0" tIns="0" bIns="0">
+            <a:spAutoFit/>
+          </a:bodyPr>
+          <a:lstStyle/>
+          <a:p>
+            <a:pPr algn="l"/>
+            <a:r>
+              <a:rPr sz="4000" b="1" i="0" spc="200">
+                <a:solidFill>
+                  <a:srgbClr val="FFFFFF"/>
+                </a:solidFill>
+                <a:latin typeface="Arial"/>
+              </a:rPr>
+              <a:t>OLYMPIC GAMES</a:t>
+            </a:r>
+          </a:p>
+        </p:txBody>
+      </p:sp>
+      <p:sp>
+        <p:nvSpPr>
+          <p:cNvPr id="6" name="TextBox 5"/>
+          <p:cNvSpPr txBox="1"/>
+          <p:nvPr/>
+        </p:nvSpPr>
+        <p:spPr>
+          <a:xfrm>
+            <a:off x="822960" y="3520440"/>
+            <a:ext cx="5486400" cy="457200"/>
+          </a:xfrm>
+          <a:prstGeom prst="rect">
+            <a:avLst/>
+          </a:prstGeom>
+          <a:noFill/>
+        </p:spPr>
+        <p:txBody>
+          <a:bodyPr wrap="square" anchor="t" lIns="0" rIns="0" tIns="0" bIns="0">
+            <a:spAutoFit/>
+          </a:bodyPr>
+          <a:lstStyle/>
+          <a:p>
+            <a:pPr algn="l"/>
+            <a:r>
+              <a:rPr sz="2200" b="1" i="0" spc="600">
+                <a:solidFill>
+                  <a:srgbClr val="4FC3D0"/>
+                </a:solidFill>
+                <a:latin typeface="Arial"/>
+              </a:rPr>
+              <a:t>BEIJING</a:t>
+            </a:r>
+          </a:p>
+        </p:txBody>
+      </p:sp>
+      <p:sp>
+        <p:nvSpPr>
+          <p:cNvPr id="7" name="Rounded Rectangle 6"/>
           <p:cNvSpPr/>
           <p:nvPr/>
         </p:nvSpPr>
         <p:spPr>
           <a:xfrm>
-            <a:off x="685800" y="1371600"/>
-            <a:ext cx="3063240" cy="4434840"/>
+            <a:off x="868680" y="4206240"/>
+            <a:ext cx="1051560" cy="68580"/>
           </a:xfrm>
           <a:prstGeom prst="roundRect">
             <a:avLst/>
@@ -6213,9 +6545,64 @@
           </a:p>
         </p:txBody>
       </p:sp>
+      <p:sp>
+        <p:nvSpPr>
+          <p:cNvPr id="8" name="TextBox 7"/>
+          <p:cNvSpPr txBox="1"/>
+          <p:nvPr/>
+        </p:nvSpPr>
+        <p:spPr>
+          <a:xfrm>
+            <a:off x="822960" y="4526280"/>
+            <a:ext cx="6217920" cy="1097280"/>
+          </a:xfrm>
+          <a:prstGeom prst="rect">
+            <a:avLst/>
+          </a:prstGeom>
+          <a:noFill/>
+        </p:spPr>
+        <p:txBody>
+          <a:bodyPr wrap="square" anchor="t" lIns="0" rIns="0" tIns="0" bIns="0">
+            <a:spAutoFit/>
+          </a:bodyPr>
+          <a:lstStyle/>
+          <a:p>
+            <a:pPr algn="l">
+              <a:lnSpc>
+                <a:spcPct val="110000"/>
+              </a:lnSpc>
+            </a:pPr>
+            <a:r>
+              <a:rPr sz="3000" b="0" i="0">
+                <a:solidFill>
+                  <a:srgbClr val="FFFFFF"/>
+                </a:solidFill>
+                <a:latin typeface="Arial"/>
+              </a:rPr>
+              <a:t>She represented </a:t>
+            </a:r>
+          </a:p>
+          <a:p>
+            <a:pPr algn="l">
+              <a:lnSpc>
+                <a:spcPct val="110000"/>
+              </a:lnSpc>
+            </a:pPr>
+            <a:r>
+              <a:rPr sz="3000" b="1" i="0">
+                <a:solidFill>
+                  <a:srgbClr val="FFB81C"/>
+                </a:solidFill>
+                <a:latin typeface="Arial"/>
+              </a:rPr>
+              <a:t>South Africa.</a:t>
+            </a:r>
+          </a:p>
+        </p:txBody>
+      </p:sp>
       <p:pic>
         <p:nvPicPr>
-          <p:cNvPr id="5" name="Picture 4" descr="luchelle-medal.jpg"/>
+          <p:cNvPr id="9" name="Picture 8" descr="natalie-beijing.jpg"/>
           <p:cNvPicPr>
             <a:picLocks noChangeAspect="1"/>
           </p:cNvPicPr>
@@ -6229,27 +6616,32 @@
         </p:blipFill>
         <p:spPr>
           <a:xfrm>
-            <a:off x="886968" y="1170432"/>
-            <a:ext cx="3063240" cy="4434840"/>
-          </a:xfrm>
-          <a:effectLst/>
+            <a:off x="8366760" y="1234440"/>
+            <a:ext cx="3108960" cy="3749039"/>
+          </a:xfrm>
           <a:prstGeom prst="roundRect">
             <a:avLst>
               <a:gd name="adj" fmla="val 9000"/>
             </a:avLst>
           </a:prstGeom>
+          <a:ln w="63500">
+            <a:solidFill>
+              <a:srgbClr val="FFB81C"/>
+            </a:solidFill>
+          </a:ln>
+          <a:effectLst/>
         </p:spPr>
       </p:pic>
       <p:sp>
         <p:nvSpPr>
-          <p:cNvPr id="6" name="TextBox 5"/>
+          <p:cNvPr id="10" name="TextBox 9"/>
           <p:cNvSpPr txBox="1"/>
           <p:nvPr/>
         </p:nvSpPr>
         <p:spPr>
           <a:xfrm>
-            <a:off x="685800" y="5961888"/>
-            <a:ext cx="3264408" cy="274320"/>
+            <a:off x="8366760" y="5138928"/>
+            <a:ext cx="3108960" cy="274320"/>
           </a:xfrm>
           <a:prstGeom prst="rect">
             <a:avLst/>
@@ -6264,138 +6656,73 @@
           <a:p>
             <a:pPr algn="ctr"/>
             <a:r>
-              <a:rPr sz="1100" b="1" i="0" spc="100">
+              <a:rPr sz="1100" b="1" i="0" spc="150">
                 <a:solidFill>
-                  <a:srgbClr val="004B36"/>
+                  <a:srgbClr val="FFB81C"/>
                 </a:solidFill>
                 <a:latin typeface="Arial"/>
               </a:rPr>
-              <a:t>Luchelle with her gymnastics medal</a:t>
-            </a:r>
-          </a:p>
-        </p:txBody>
-      </p:sp>
-      <p:sp>
-        <p:nvSpPr>
-          <p:cNvPr id="7" name="TextBox 6"/>
-          <p:cNvSpPr txBox="1"/>
-          <p:nvPr/>
-        </p:nvSpPr>
-        <p:spPr>
-          <a:xfrm>
-            <a:off x="4846320" y="1371600"/>
-            <a:ext cx="6400800" cy="365760"/>
-          </a:xfrm>
-          <a:prstGeom prst="rect">
-            <a:avLst/>
-          </a:prstGeom>
-          <a:noFill/>
-        </p:spPr>
-        <p:txBody>
-          <a:bodyPr wrap="square" anchor="t" lIns="0" rIns="0" tIns="0" bIns="0">
-            <a:spAutoFit/>
-          </a:bodyPr>
-          <a:lstStyle/>
-          <a:p>
-            <a:pPr algn="l"/>
-            <a:r>
-              <a:rPr sz="1500" b="1" i="0" spc="250">
-                <a:solidFill>
-                  <a:srgbClr val="007749"/>
-                </a:solidFill>
-                <a:latin typeface="Arial"/>
-              </a:rPr>
-              <a:t>JUST LIKE MY HERO, I KEEP GOING</a:t>
-            </a:r>
-          </a:p>
-        </p:txBody>
-      </p:sp>
-      <p:sp>
-        <p:nvSpPr>
-          <p:cNvPr id="8" name="TextBox 7"/>
-          <p:cNvSpPr txBox="1"/>
-          <p:nvPr/>
-        </p:nvSpPr>
-        <p:spPr>
-          <a:xfrm>
-            <a:off x="4809744" y="1828800"/>
-            <a:ext cx="6583680" cy="1600200"/>
-          </a:xfrm>
-          <a:prstGeom prst="rect">
-            <a:avLst/>
-          </a:prstGeom>
-          <a:noFill/>
-        </p:spPr>
-        <p:txBody>
-          <a:bodyPr wrap="square" anchor="t" lIns="0" rIns="0" tIns="0" bIns="0">
-            <a:spAutoFit/>
-          </a:bodyPr>
-          <a:lstStyle/>
-          <a:p>
-            <a:pPr algn="l">
-              <a:lnSpc>
-                <a:spcPct val="98000"/>
-              </a:lnSpc>
-            </a:pPr>
-            <a:r>
-              <a:rPr sz="5200" b="1" i="0">
-                <a:solidFill>
-                  <a:srgbClr val="004B36"/>
-                </a:solidFill>
-                <a:latin typeface="Arial"/>
-              </a:rPr>
-              <a:t>Why she is my hero</a:t>
-            </a:r>
-          </a:p>
-        </p:txBody>
-      </p:sp>
-      <p:sp>
-        <p:nvSpPr>
-          <p:cNvPr id="9" name="TextBox 8"/>
-          <p:cNvSpPr txBox="1"/>
-          <p:nvPr/>
-        </p:nvSpPr>
-        <p:spPr>
-          <a:xfrm>
-            <a:off x="4846320" y="3520440"/>
-            <a:ext cx="6035040" cy="548640"/>
-          </a:xfrm>
-          <a:prstGeom prst="rect">
-            <a:avLst/>
-          </a:prstGeom>
-          <a:noFill/>
-        </p:spPr>
-        <p:txBody>
-          <a:bodyPr wrap="square" anchor="t" lIns="0" rIns="0" tIns="0" bIns="0">
-            <a:spAutoFit/>
-          </a:bodyPr>
-          <a:lstStyle/>
-          <a:p>
-            <a:pPr algn="l"/>
-            <a:r>
-              <a:rPr sz="2400" b="0" i="0">
-                <a:solidFill>
-                  <a:srgbClr val="0E241C"/>
-                </a:solidFill>
-                <a:latin typeface="Arial"/>
-              </a:rPr>
-              <a:t>She was a great swimmer.</a:t>
-            </a:r>
-          </a:p>
-        </p:txBody>
-      </p:sp>
-      <p:sp>
-        <p:nvSpPr>
-          <p:cNvPr id="10" name="Rounded Rectangle 9"/>
+              <a:t>BEIJING 2008  •  GOLD MEDAL</a:t>
+            </a:r>
+          </a:p>
+        </p:txBody>
+      </p:sp>
+      <p:sp>
+        <p:nvSpPr>
+          <p:cNvPr id="11" name="Rectangle 10"/>
           <p:cNvSpPr/>
           <p:nvPr/>
         </p:nvSpPr>
         <p:spPr>
           <a:xfrm>
-            <a:off x="4901184" y="4224528"/>
-            <a:ext cx="1051560" cy="68580"/>
-          </a:xfrm>
-          <a:prstGeom prst="roundRect">
+            <a:off x="0" y="6794500"/>
+            <a:ext cx="12191695" cy="63500"/>
+          </a:xfrm>
+          <a:prstGeom prst="rect">
+            <a:avLst/>
+          </a:prstGeom>
+          <a:solidFill>
+            <a:srgbClr val="2A4A3E"/>
+          </a:solidFill>
+          <a:ln>
+            <a:noFill/>
+          </a:ln>
+          <a:effectLst/>
+        </p:spPr>
+        <p:style>
+          <a:lnRef idx="1">
+            <a:schemeClr val="accent1"/>
+          </a:lnRef>
+          <a:fillRef idx="3">
+            <a:schemeClr val="accent1"/>
+          </a:fillRef>
+          <a:effectRef idx="2">
+            <a:schemeClr val="accent1"/>
+          </a:effectRef>
+          <a:fontRef idx="minor">
+            <a:schemeClr val="lt1"/>
+          </a:fontRef>
+        </p:style>
+        <p:txBody>
+          <a:bodyPr rtlCol="0" anchor="ctr"/>
+          <a:lstStyle/>
+          <a:p>
+            <a:pPr algn="ctr"/>
+          </a:p>
+        </p:txBody>
+      </p:sp>
+      <p:sp>
+        <p:nvSpPr>
+          <p:cNvPr id="12" name="Rectangle 11"/>
+          <p:cNvSpPr/>
+          <p:nvPr/>
+        </p:nvSpPr>
+        <p:spPr>
+          <a:xfrm>
+            <a:off x="0" y="6794500"/>
+            <a:ext cx="8708353" cy="63500"/>
+          </a:xfrm>
+          <a:prstGeom prst="rect">
             <a:avLst/>
           </a:prstGeom>
           <a:solidFill>
@@ -6430,150 +6757,7 @@
       </p:sp>
       <p:sp>
         <p:nvSpPr>
-          <p:cNvPr id="11" name="TextBox 10"/>
-          <p:cNvSpPr txBox="1"/>
-          <p:nvPr/>
-        </p:nvSpPr>
-        <p:spPr>
-          <a:xfrm>
-            <a:off x="4846320" y="4526280"/>
-            <a:ext cx="6400800" cy="1188720"/>
-          </a:xfrm>
-          <a:prstGeom prst="rect">
-            <a:avLst/>
-          </a:prstGeom>
-          <a:noFill/>
-        </p:spPr>
-        <p:txBody>
-          <a:bodyPr wrap="square" anchor="t" lIns="0" rIns="0" tIns="0" bIns="0">
-            <a:spAutoFit/>
-          </a:bodyPr>
-          <a:lstStyle/>
-          <a:p>
-            <a:pPr algn="l">
-              <a:lnSpc>
-                <a:spcPct val="112000"/>
-              </a:lnSpc>
-            </a:pPr>
-            <a:r>
-              <a:rPr sz="3000" b="1" i="0">
-                <a:solidFill>
-                  <a:srgbClr val="D22630"/>
-                </a:solidFill>
-                <a:latin typeface="Arial"/>
-              </a:rPr>
-              <a:t>Most importantly,</a:t>
-            </a:r>
-          </a:p>
-          <a:p>
-            <a:pPr algn="l">
-              <a:lnSpc>
-                <a:spcPct val="112000"/>
-              </a:lnSpc>
-            </a:pPr>
-            <a:r>
-              <a:rPr sz="3000" b="1" i="0">
-                <a:solidFill>
-                  <a:srgbClr val="D22630"/>
-                </a:solidFill>
-                <a:latin typeface="Arial"/>
-              </a:rPr>
-              <a:t>she never gave up.</a:t>
-            </a:r>
-          </a:p>
-        </p:txBody>
-      </p:sp>
-      <p:sp>
-        <p:nvSpPr>
-          <p:cNvPr id="12" name="Rectangle 11"/>
-          <p:cNvSpPr/>
-          <p:nvPr/>
-        </p:nvSpPr>
-        <p:spPr>
-          <a:xfrm>
-            <a:off x="0" y="6794500"/>
-            <a:ext cx="12191695" cy="63500"/>
-          </a:xfrm>
-          <a:prstGeom prst="rect">
-            <a:avLst/>
-          </a:prstGeom>
-          <a:solidFill>
-            <a:srgbClr val="E3D9C2"/>
-          </a:solidFill>
-          <a:ln>
-            <a:noFill/>
-          </a:ln>
-          <a:effectLst/>
-        </p:spPr>
-        <p:style>
-          <a:lnRef idx="1">
-            <a:schemeClr val="accent1"/>
-          </a:lnRef>
-          <a:fillRef idx="3">
-            <a:schemeClr val="accent1"/>
-          </a:fillRef>
-          <a:effectRef idx="2">
-            <a:schemeClr val="accent1"/>
-          </a:effectRef>
-          <a:fontRef idx="minor">
-            <a:schemeClr val="lt1"/>
-          </a:fontRef>
-        </p:style>
-        <p:txBody>
-          <a:bodyPr rtlCol="0" anchor="ctr"/>
-          <a:lstStyle/>
-          <a:p>
-            <a:pPr algn="ctr"/>
-          </a:p>
-        </p:txBody>
-      </p:sp>
-      <p:sp>
-        <p:nvSpPr>
-          <p:cNvPr id="13" name="Rectangle 12"/>
-          <p:cNvSpPr/>
-          <p:nvPr/>
-        </p:nvSpPr>
-        <p:spPr>
-          <a:xfrm>
-            <a:off x="0" y="6794500"/>
-            <a:ext cx="10159745" cy="63500"/>
-          </a:xfrm>
-          <a:prstGeom prst="rect">
-            <a:avLst/>
-          </a:prstGeom>
-          <a:solidFill>
-            <a:srgbClr val="FFB81C"/>
-          </a:solidFill>
-          <a:ln>
-            <a:noFill/>
-          </a:ln>
-          <a:effectLst/>
-        </p:spPr>
-        <p:style>
-          <a:lnRef idx="1">
-            <a:schemeClr val="accent1"/>
-          </a:lnRef>
-          <a:fillRef idx="3">
-            <a:schemeClr val="accent1"/>
-          </a:fillRef>
-          <a:effectRef idx="2">
-            <a:schemeClr val="accent1"/>
-          </a:effectRef>
-          <a:fontRef idx="minor">
-            <a:schemeClr val="lt1"/>
-          </a:fontRef>
-        </p:style>
-        <p:txBody>
-          <a:bodyPr rtlCol="0" anchor="ctr"/>
-          <a:lstStyle/>
-          <a:p>
-            <a:pPr algn="ctr"/>
-          </a:p>
-        </p:txBody>
-      </p:sp>
-      <p:sp>
-        <p:nvSpPr>
-          <p:cNvPr id="14" name="TextBox 13"/>
+          <p:cNvPr id="13" name="TextBox 12"/>
           <p:cNvSpPr txBox="1"/>
           <p:nvPr/>
         </p:nvSpPr>
@@ -6606,18 +6790,18 @@
             <a:r>
               <a:rPr sz="1200" b="1" i="0" spc="200">
                 <a:solidFill>
-                  <a:srgbClr val="004B36"/>
+                  <a:srgbClr val="FFFFFF"/>
                 </a:solidFill>
                 <a:latin typeface="Arial"/>
               </a:rPr>
-              <a:t> / 06</a:t>
+              <a:t> / 07</a:t>
             </a:r>
           </a:p>
         </p:txBody>
       </p:sp>
       <p:pic>
         <p:nvPicPr>
-          <p:cNvPr id="15" name="Picture 14" descr="panorama-crest.png"/>
+          <p:cNvPr id="14" name="Picture 13" descr="panorama-crest.png"/>
           <p:cNvPicPr>
             <a:picLocks noChangeAspect="1"/>
           </p:cNvPicPr>
@@ -6672,6 +6856,582 @@
             <a:avLst/>
           </a:prstGeom>
           <a:solidFill>
+            <a:srgbClr val="FFF6E5"/>
+          </a:solidFill>
+          <a:ln>
+            <a:noFill/>
+          </a:ln>
+          <a:effectLst/>
+        </p:spPr>
+        <p:style>
+          <a:lnRef idx="1">
+            <a:schemeClr val="accent1"/>
+          </a:lnRef>
+          <a:fillRef idx="3">
+            <a:schemeClr val="accent1"/>
+          </a:fillRef>
+          <a:effectRef idx="2">
+            <a:schemeClr val="accent1"/>
+          </a:effectRef>
+          <a:fontRef idx="minor">
+            <a:schemeClr val="lt1"/>
+          </a:fontRef>
+        </p:style>
+        <p:txBody>
+          <a:bodyPr rtlCol="0" anchor="ctr"/>
+          <a:lstStyle/>
+          <a:p>
+            <a:pPr algn="ctr"/>
+          </a:p>
+        </p:txBody>
+      </p:sp>
+      <p:sp>
+        <p:nvSpPr>
+          <p:cNvPr id="3" name="Rectangle 2"/>
+          <p:cNvSpPr/>
+          <p:nvPr/>
+        </p:nvSpPr>
+        <p:spPr>
+          <a:xfrm>
+            <a:off x="12027103" y="0"/>
+            <a:ext cx="164592" cy="6858000"/>
+          </a:xfrm>
+          <a:prstGeom prst="rect">
+            <a:avLst/>
+          </a:prstGeom>
+          <a:solidFill>
+            <a:srgbClr val="007749"/>
+          </a:solidFill>
+          <a:ln>
+            <a:noFill/>
+          </a:ln>
+          <a:effectLst/>
+        </p:spPr>
+        <p:style>
+          <a:lnRef idx="1">
+            <a:schemeClr val="accent1"/>
+          </a:lnRef>
+          <a:fillRef idx="3">
+            <a:schemeClr val="accent1"/>
+          </a:fillRef>
+          <a:effectRef idx="2">
+            <a:schemeClr val="accent1"/>
+          </a:effectRef>
+          <a:fontRef idx="minor">
+            <a:schemeClr val="lt1"/>
+          </a:fontRef>
+        </p:style>
+        <p:txBody>
+          <a:bodyPr rtlCol="0" anchor="ctr"/>
+          <a:lstStyle/>
+          <a:p>
+            <a:pPr algn="ctr"/>
+          </a:p>
+        </p:txBody>
+      </p:sp>
+      <p:sp>
+        <p:nvSpPr>
+          <p:cNvPr id="4" name="Rounded Rectangle 3"/>
+          <p:cNvSpPr/>
+          <p:nvPr/>
+        </p:nvSpPr>
+        <p:spPr>
+          <a:xfrm>
+            <a:off x="685800" y="1371600"/>
+            <a:ext cx="3063240" cy="4434840"/>
+          </a:xfrm>
+          <a:prstGeom prst="roundRect">
+            <a:avLst/>
+          </a:prstGeom>
+          <a:solidFill>
+            <a:srgbClr val="FFB81C"/>
+          </a:solidFill>
+          <a:ln>
+            <a:noFill/>
+          </a:ln>
+          <a:effectLst/>
+        </p:spPr>
+        <p:style>
+          <a:lnRef idx="1">
+            <a:schemeClr val="accent1"/>
+          </a:lnRef>
+          <a:fillRef idx="3">
+            <a:schemeClr val="accent1"/>
+          </a:fillRef>
+          <a:effectRef idx="2">
+            <a:schemeClr val="accent1"/>
+          </a:effectRef>
+          <a:fontRef idx="minor">
+            <a:schemeClr val="lt1"/>
+          </a:fontRef>
+        </p:style>
+        <p:txBody>
+          <a:bodyPr rtlCol="0" anchor="ctr"/>
+          <a:lstStyle/>
+          <a:p>
+            <a:pPr algn="ctr"/>
+          </a:p>
+        </p:txBody>
+      </p:sp>
+      <p:pic>
+        <p:nvPicPr>
+          <p:cNvPr id="5" name="Picture 4" descr="luchelle-medal.jpg"/>
+          <p:cNvPicPr>
+            <a:picLocks noChangeAspect="1"/>
+          </p:cNvPicPr>
+          <p:nvPr/>
+        </p:nvPicPr>
+        <p:blipFill>
+          <a:blip r:embed="rId2"/>
+          <a:stretch>
+            <a:fillRect/>
+          </a:stretch>
+        </p:blipFill>
+        <p:spPr>
+          <a:xfrm>
+            <a:off x="886968" y="1170432"/>
+            <a:ext cx="3063240" cy="4434840"/>
+          </a:xfrm>
+          <a:effectLst/>
+          <a:prstGeom prst="roundRect">
+            <a:avLst>
+              <a:gd name="adj" fmla="val 9000"/>
+            </a:avLst>
+          </a:prstGeom>
+        </p:spPr>
+      </p:pic>
+      <p:sp>
+        <p:nvSpPr>
+          <p:cNvPr id="6" name="TextBox 5"/>
+          <p:cNvSpPr txBox="1"/>
+          <p:nvPr/>
+        </p:nvSpPr>
+        <p:spPr>
+          <a:xfrm>
+            <a:off x="685800" y="5961888"/>
+            <a:ext cx="3264408" cy="274320"/>
+          </a:xfrm>
+          <a:prstGeom prst="rect">
+            <a:avLst/>
+          </a:prstGeom>
+          <a:noFill/>
+        </p:spPr>
+        <p:txBody>
+          <a:bodyPr wrap="square" anchor="t" lIns="0" rIns="0" tIns="0" bIns="0">
+            <a:spAutoFit/>
+          </a:bodyPr>
+          <a:lstStyle/>
+          <a:p>
+            <a:pPr algn="ctr"/>
+            <a:r>
+              <a:rPr sz="1100" b="1" i="0" spc="100">
+                <a:solidFill>
+                  <a:srgbClr val="004B36"/>
+                </a:solidFill>
+                <a:latin typeface="Arial"/>
+              </a:rPr>
+              <a:t>Luchelle with her gymnastics medal</a:t>
+            </a:r>
+          </a:p>
+        </p:txBody>
+      </p:sp>
+      <p:sp>
+        <p:nvSpPr>
+          <p:cNvPr id="7" name="TextBox 6"/>
+          <p:cNvSpPr txBox="1"/>
+          <p:nvPr/>
+        </p:nvSpPr>
+        <p:spPr>
+          <a:xfrm>
+            <a:off x="4846320" y="1371600"/>
+            <a:ext cx="6400800" cy="365760"/>
+          </a:xfrm>
+          <a:prstGeom prst="rect">
+            <a:avLst/>
+          </a:prstGeom>
+          <a:noFill/>
+        </p:spPr>
+        <p:txBody>
+          <a:bodyPr wrap="square" anchor="t" lIns="0" rIns="0" tIns="0" bIns="0">
+            <a:spAutoFit/>
+          </a:bodyPr>
+          <a:lstStyle/>
+          <a:p>
+            <a:pPr algn="l"/>
+            <a:r>
+              <a:rPr sz="1500" b="1" i="0" spc="250">
+                <a:solidFill>
+                  <a:srgbClr val="007749"/>
+                </a:solidFill>
+                <a:latin typeface="Arial"/>
+              </a:rPr>
+              <a:t>JUST LIKE MY HERO, I KEEP GOING</a:t>
+            </a:r>
+          </a:p>
+        </p:txBody>
+      </p:sp>
+      <p:sp>
+        <p:nvSpPr>
+          <p:cNvPr id="8" name="TextBox 7"/>
+          <p:cNvSpPr txBox="1"/>
+          <p:nvPr/>
+        </p:nvSpPr>
+        <p:spPr>
+          <a:xfrm>
+            <a:off x="4809744" y="1828800"/>
+            <a:ext cx="6583680" cy="1600200"/>
+          </a:xfrm>
+          <a:prstGeom prst="rect">
+            <a:avLst/>
+          </a:prstGeom>
+          <a:noFill/>
+        </p:spPr>
+        <p:txBody>
+          <a:bodyPr wrap="square" anchor="t" lIns="0" rIns="0" tIns="0" bIns="0">
+            <a:spAutoFit/>
+          </a:bodyPr>
+          <a:lstStyle/>
+          <a:p>
+            <a:pPr algn="l">
+              <a:lnSpc>
+                <a:spcPct val="98000"/>
+              </a:lnSpc>
+            </a:pPr>
+            <a:r>
+              <a:rPr sz="5200" b="1" i="0">
+                <a:solidFill>
+                  <a:srgbClr val="004B36"/>
+                </a:solidFill>
+                <a:latin typeface="Arial"/>
+              </a:rPr>
+              <a:t>Why she is my hero</a:t>
+            </a:r>
+          </a:p>
+        </p:txBody>
+      </p:sp>
+      <p:sp>
+        <p:nvSpPr>
+          <p:cNvPr id="9" name="TextBox 8"/>
+          <p:cNvSpPr txBox="1"/>
+          <p:nvPr/>
+        </p:nvSpPr>
+        <p:spPr>
+          <a:xfrm>
+            <a:off x="4846320" y="3520440"/>
+            <a:ext cx="6035040" cy="548640"/>
+          </a:xfrm>
+          <a:prstGeom prst="rect">
+            <a:avLst/>
+          </a:prstGeom>
+          <a:noFill/>
+        </p:spPr>
+        <p:txBody>
+          <a:bodyPr wrap="square" anchor="t" lIns="0" rIns="0" tIns="0" bIns="0">
+            <a:spAutoFit/>
+          </a:bodyPr>
+          <a:lstStyle/>
+          <a:p>
+            <a:pPr algn="l"/>
+            <a:r>
+              <a:rPr sz="2400" b="0" i="0">
+                <a:solidFill>
+                  <a:srgbClr val="0E241C"/>
+                </a:solidFill>
+                <a:latin typeface="Arial"/>
+              </a:rPr>
+              <a:t>She was a great swimmer.</a:t>
+            </a:r>
+          </a:p>
+        </p:txBody>
+      </p:sp>
+      <p:sp>
+        <p:nvSpPr>
+          <p:cNvPr id="10" name="Rounded Rectangle 9"/>
+          <p:cNvSpPr/>
+          <p:nvPr/>
+        </p:nvSpPr>
+        <p:spPr>
+          <a:xfrm>
+            <a:off x="4901184" y="4224528"/>
+            <a:ext cx="1051560" cy="68580"/>
+          </a:xfrm>
+          <a:prstGeom prst="roundRect">
+            <a:avLst/>
+          </a:prstGeom>
+          <a:solidFill>
+            <a:srgbClr val="FFB81C"/>
+          </a:solidFill>
+          <a:ln>
+            <a:noFill/>
+          </a:ln>
+          <a:effectLst/>
+        </p:spPr>
+        <p:style>
+          <a:lnRef idx="1">
+            <a:schemeClr val="accent1"/>
+          </a:lnRef>
+          <a:fillRef idx="3">
+            <a:schemeClr val="accent1"/>
+          </a:fillRef>
+          <a:effectRef idx="2">
+            <a:schemeClr val="accent1"/>
+          </a:effectRef>
+          <a:fontRef idx="minor">
+            <a:schemeClr val="lt1"/>
+          </a:fontRef>
+        </p:style>
+        <p:txBody>
+          <a:bodyPr rtlCol="0" anchor="ctr"/>
+          <a:lstStyle/>
+          <a:p>
+            <a:pPr algn="ctr"/>
+          </a:p>
+        </p:txBody>
+      </p:sp>
+      <p:sp>
+        <p:nvSpPr>
+          <p:cNvPr id="11" name="TextBox 10"/>
+          <p:cNvSpPr txBox="1"/>
+          <p:nvPr/>
+        </p:nvSpPr>
+        <p:spPr>
+          <a:xfrm>
+            <a:off x="4846320" y="4526280"/>
+            <a:ext cx="6400800" cy="1188720"/>
+          </a:xfrm>
+          <a:prstGeom prst="rect">
+            <a:avLst/>
+          </a:prstGeom>
+          <a:noFill/>
+        </p:spPr>
+        <p:txBody>
+          <a:bodyPr wrap="square" anchor="t" lIns="0" rIns="0" tIns="0" bIns="0">
+            <a:spAutoFit/>
+          </a:bodyPr>
+          <a:lstStyle/>
+          <a:p>
+            <a:pPr algn="l">
+              <a:lnSpc>
+                <a:spcPct val="112000"/>
+              </a:lnSpc>
+            </a:pPr>
+            <a:r>
+              <a:rPr sz="3000" b="1" i="0">
+                <a:solidFill>
+                  <a:srgbClr val="D22630"/>
+                </a:solidFill>
+                <a:latin typeface="Arial"/>
+              </a:rPr>
+              <a:t>Most importantly,</a:t>
+            </a:r>
+          </a:p>
+          <a:p>
+            <a:pPr algn="l">
+              <a:lnSpc>
+                <a:spcPct val="112000"/>
+              </a:lnSpc>
+            </a:pPr>
+            <a:r>
+              <a:rPr sz="3000" b="1" i="0">
+                <a:solidFill>
+                  <a:srgbClr val="D22630"/>
+                </a:solidFill>
+                <a:latin typeface="Arial"/>
+              </a:rPr>
+              <a:t>she never gave up.</a:t>
+            </a:r>
+          </a:p>
+        </p:txBody>
+      </p:sp>
+      <p:sp>
+        <p:nvSpPr>
+          <p:cNvPr id="12" name="Rectangle 11"/>
+          <p:cNvSpPr/>
+          <p:nvPr/>
+        </p:nvSpPr>
+        <p:spPr>
+          <a:xfrm>
+            <a:off x="0" y="6794500"/>
+            <a:ext cx="12191695" cy="63500"/>
+          </a:xfrm>
+          <a:prstGeom prst="rect">
+            <a:avLst/>
+          </a:prstGeom>
+          <a:solidFill>
+            <a:srgbClr val="E3D9C2"/>
+          </a:solidFill>
+          <a:ln>
+            <a:noFill/>
+          </a:ln>
+          <a:effectLst/>
+        </p:spPr>
+        <p:style>
+          <a:lnRef idx="1">
+            <a:schemeClr val="accent1"/>
+          </a:lnRef>
+          <a:fillRef idx="3">
+            <a:schemeClr val="accent1"/>
+          </a:fillRef>
+          <a:effectRef idx="2">
+            <a:schemeClr val="accent1"/>
+          </a:effectRef>
+          <a:fontRef idx="minor">
+            <a:schemeClr val="lt1"/>
+          </a:fontRef>
+        </p:style>
+        <p:txBody>
+          <a:bodyPr rtlCol="0" anchor="ctr"/>
+          <a:lstStyle/>
+          <a:p>
+            <a:pPr algn="ctr"/>
+          </a:p>
+        </p:txBody>
+      </p:sp>
+      <p:sp>
+        <p:nvSpPr>
+          <p:cNvPr id="13" name="Rectangle 12"/>
+          <p:cNvSpPr/>
+          <p:nvPr/>
+        </p:nvSpPr>
+        <p:spPr>
+          <a:xfrm>
+            <a:off x="0" y="6794500"/>
+            <a:ext cx="10450024" cy="63500"/>
+          </a:xfrm>
+          <a:prstGeom prst="rect">
+            <a:avLst/>
+          </a:prstGeom>
+          <a:solidFill>
+            <a:srgbClr val="FFB81C"/>
+          </a:solidFill>
+          <a:ln>
+            <a:noFill/>
+          </a:ln>
+          <a:effectLst/>
+        </p:spPr>
+        <p:style>
+          <a:lnRef idx="1">
+            <a:schemeClr val="accent1"/>
+          </a:lnRef>
+          <a:fillRef idx="3">
+            <a:schemeClr val="accent1"/>
+          </a:fillRef>
+          <a:effectRef idx="2">
+            <a:schemeClr val="accent1"/>
+          </a:effectRef>
+          <a:fontRef idx="minor">
+            <a:schemeClr val="lt1"/>
+          </a:fontRef>
+        </p:style>
+        <p:txBody>
+          <a:bodyPr rtlCol="0" anchor="ctr"/>
+          <a:lstStyle/>
+          <a:p>
+            <a:pPr algn="ctr"/>
+          </a:p>
+        </p:txBody>
+      </p:sp>
+      <p:sp>
+        <p:nvSpPr>
+          <p:cNvPr id="14" name="TextBox 13"/>
+          <p:cNvSpPr txBox="1"/>
+          <p:nvPr/>
+        </p:nvSpPr>
+        <p:spPr>
+          <a:xfrm>
+            <a:off x="10637215" y="6382512"/>
+            <a:ext cx="1143000" cy="274320"/>
+          </a:xfrm>
+          <a:prstGeom prst="rect">
+            <a:avLst/>
+          </a:prstGeom>
+          <a:noFill/>
+        </p:spPr>
+        <p:txBody>
+          <a:bodyPr wrap="square" anchor="t" lIns="0" rIns="0" tIns="0" bIns="0">
+            <a:spAutoFit/>
+          </a:bodyPr>
+          <a:lstStyle/>
+          <a:p>
+            <a:pPr algn="r"/>
+            <a:r>
+              <a:rPr sz="1200" b="1" i="0" spc="200">
+                <a:solidFill>
+                  <a:srgbClr val="FFB81C"/>
+                </a:solidFill>
+                <a:latin typeface="Arial"/>
+              </a:rPr>
+              <a:t>06</a:t>
+            </a:r>
+            <a:r>
+              <a:rPr sz="1200" b="1" i="0" spc="200">
+                <a:solidFill>
+                  <a:srgbClr val="004B36"/>
+                </a:solidFill>
+                <a:latin typeface="Arial"/>
+              </a:rPr>
+              <a:t> / 07</a:t>
+            </a:r>
+          </a:p>
+        </p:txBody>
+      </p:sp>
+      <p:pic>
+        <p:nvPicPr>
+          <p:cNvPr id="15" name="Picture 14" descr="panorama-crest.png"/>
+          <p:cNvPicPr>
+            <a:picLocks noChangeAspect="1"/>
+          </p:cNvPicPr>
+          <p:nvPr/>
+        </p:nvPicPr>
+        <p:blipFill>
+          <a:blip r:embed="rId3"/>
+          <a:stretch>
+            <a:fillRect/>
+          </a:stretch>
+        </p:blipFill>
+        <p:spPr>
+          <a:xfrm>
+            <a:off x="11140135" y="347472"/>
+            <a:ext cx="566928" cy="566928"/>
+          </a:xfrm>
+          <a:prstGeom prst="rect">
+            <a:avLst/>
+          </a:prstGeom>
+        </p:spPr>
+      </p:pic>
+    </p:spTree>
+  </p:cSld>
+  <p:clrMapOvr>
+    <a:masterClrMapping/>
+  </p:clrMapOvr>
+</p:sld>
+</file>
+
+<file path=ppt/slides/slide7.xml><?xml version="1.0" encoding="utf-8"?>
+<p:sld xmlns:a="http://schemas.openxmlformats.org/drawingml/2006/main" xmlns:p="http://schemas.openxmlformats.org/presentationml/2006/main" xmlns:r="http://schemas.openxmlformats.org/officeDocument/2006/relationships">
+  <p:cSld>
+    <p:spTree>
+      <p:nvGrpSpPr>
+        <p:cNvPr id="1" name=""/>
+        <p:cNvGrpSpPr/>
+        <p:nvPr/>
+      </p:nvGrpSpPr>
+      <p:grpSpPr/>
+      <p:sp>
+        <p:nvSpPr>
+          <p:cNvPr id="2" name="Rectangle 1"/>
+          <p:cNvSpPr/>
+          <p:nvPr/>
+        </p:nvSpPr>
+        <p:spPr>
+          <a:xfrm>
+            <a:off x="0" y="0"/>
+            <a:ext cx="12191695" cy="6858000"/>
+          </a:xfrm>
+          <a:prstGeom prst="rect">
+            <a:avLst/>
+          </a:prstGeom>
+          <a:solidFill>
             <a:srgbClr val="004B36"/>
           </a:solidFill>
           <a:ln>
@@ -6907,7 +7667,7 @@
                 </a:solidFill>
                 <a:latin typeface="Arial"/>
               </a:rPr>
-              <a:t>06</a:t>
+              <a:t>07</a:t>
             </a:r>
             <a:r>
               <a:rPr sz="1200" b="1" i="0" spc="200">
@@ -6916,7 +7676,7 @@
                 </a:solidFill>
                 <a:latin typeface="Arial"/>
               </a:rPr>
-              <a:t> / 06</a:t>
+              <a:t> / 07</a:t>
             </a:r>
           </a:p>
         </p:txBody>

</xml_diff>